<commit_message>
Rebrand application, API, documentation, and deliverables to ClaimLens
</commit_message>
<xml_diff>
--- a/presentation/Project_Presentation.pptx
+++ b/presentation/Project_Presentation.pptx
@@ -3169,7 +3169,7 @@
               </a:defRPr>
             </a:pPr>
             <a:r>
-              <a:t>AI-Powered Insurance Claims Assistant</a:t>
+              <a:t>ClaimLens: AI-Powered Insurance Claims Assistant</a:t>
             </a:r>
           </a:p>
           <a:p>
@@ -3297,7 +3297,7 @@
               </a:defRPr>
             </a:pPr>
             <a:r>
-              <a:t>CAPSTONE PROJECT: AI-POWERED INSURANCE CLAIMS ASSISTANT</a:t>
+              <a:t>CAPSTONE PROJECT: CLAIMLENS AI CLAIMS ASSISTANT</a:t>
             </a:r>
           </a:p>
           <a:p>
@@ -3717,7 +3717,7 @@
               </a:defRPr>
             </a:pPr>
             <a:r>
-              <a:t>CAPSTONE PROJECT: AI-POWERED INSURANCE CLAIMS ASSISTANT</a:t>
+              <a:t>CAPSTONE PROJECT: CLAIMLENS AI CLAIMS ASSISTANT</a:t>
             </a:r>
           </a:p>
           <a:p>
@@ -4292,7 +4292,7 @@
               </a:defRPr>
             </a:pPr>
             <a:r>
-              <a:t>CAPSTONE PROJECT: AI-POWERED INSURANCE CLAIMS ASSISTANT</a:t>
+              <a:t>CAPSTONE PROJECT: CLAIMLENS AI CLAIMS ASSISTANT</a:t>
             </a:r>
           </a:p>
           <a:p>
@@ -5022,7 +5022,7 @@
               </a:defRPr>
             </a:pPr>
             <a:r>
-              <a:t>CAPSTONE PROJECT: AI-POWERED INSURANCE CLAIMS ASSISTANT</a:t>
+              <a:t>CAPSTONE PROJECT: CLAIMLENS AI CLAIMS ASSISTANT</a:t>
             </a:r>
           </a:p>
           <a:p>
@@ -5442,7 +5442,7 @@
               </a:defRPr>
             </a:pPr>
             <a:r>
-              <a:t>CAPSTONE PROJECT: AI-POWERED INSURANCE CLAIMS ASSISTANT</a:t>
+              <a:t>CAPSTONE PROJECT: CLAIMLENS AI CLAIMS ASSISTANT</a:t>
             </a:r>
           </a:p>
           <a:p>
@@ -5862,7 +5862,7 @@
               </a:defRPr>
             </a:pPr>
             <a:r>
-              <a:t>CAPSTONE PROJECT: AI-POWERED INSURANCE CLAIMS ASSISTANT</a:t>
+              <a:t>CAPSTONE PROJECT: CLAIMLENS AI CLAIMS ASSISTANT</a:t>
             </a:r>
           </a:p>
           <a:p>

</xml_diff>

<commit_message>
Update architecture diagram asset, PDF deliverable, and presentation deck
</commit_message>
<xml_diff>
--- a/presentation/Project_Presentation.pptx
+++ b/presentation/Project_Presentation.pptx
@@ -3729,176 +3729,45 @@
               </a:defRPr>
             </a:pPr>
             <a:r>
-              <a:t>End-to-End System Architecture</a:t>
-            </a:r>
-          </a:p>
-        </p:txBody>
-      </p:sp>
-      <p:sp>
-        <p:nvSpPr>
-          <p:cNvPr id="4" name="Rectangle 3"/>
-          <p:cNvSpPr/>
+              <a:t>ClaimLens — End-to-End System Architecture</a:t>
+            </a:r>
+          </a:p>
+        </p:txBody>
+      </p:sp>
+      <p:pic>
+        <p:nvPicPr>
+          <p:cNvPr id="4" name="Picture 3" descr="Architecture_Diagram.png"/>
+          <p:cNvPicPr>
+            <a:picLocks noChangeAspect="1"/>
+          </p:cNvPicPr>
           <p:nvPr/>
-        </p:nvSpPr>
+        </p:nvPicPr>
+        <p:blipFill>
+          <a:blip r:embed="rId2"/>
+          <a:stretch>
+            <a:fillRect/>
+          </a:stretch>
+        </p:blipFill>
         <p:spPr>
           <a:xfrm>
-            <a:off x="731520" y="1371600"/>
-            <a:ext cx="3291840" cy="4937760"/>
+            <a:off x="548640" y="1371600"/>
+            <a:ext cx="7498079" cy="4992624"/>
           </a:xfrm>
           <a:prstGeom prst="rect">
             <a:avLst/>
           </a:prstGeom>
-          <a:solidFill>
-            <a:srgbClr val="F8FAFC"/>
-          </a:solidFill>
-          <a:ln w="19050">
-            <a:solidFill>
-              <a:srgbClr val="CBD5E1"/>
-            </a:solidFill>
-          </a:ln>
         </p:spPr>
-        <p:style>
-          <a:lnRef idx="1">
-            <a:schemeClr val="accent1"/>
-          </a:lnRef>
-          <a:fillRef idx="3">
-            <a:schemeClr val="accent1"/>
-          </a:fillRef>
-          <a:effectRef idx="2">
-            <a:schemeClr val="accent1"/>
-          </a:effectRef>
-          <a:fontRef idx="minor">
-            <a:schemeClr val="lt1"/>
-          </a:fontRef>
-        </p:style>
-        <p:txBody>
-          <a:bodyPr rtlCol="0" anchor="ctr"/>
-          <a:lstStyle/>
-          <a:p>
-            <a:pPr algn="ctr"/>
-          </a:p>
-        </p:txBody>
-      </p:sp>
-      <p:sp>
-        <p:nvSpPr>
-          <p:cNvPr id="5" name="TextBox 4"/>
-          <p:cNvSpPr txBox="1"/>
+      </p:pic>
+      <p:sp>
+        <p:nvSpPr>
+          <p:cNvPr id="5" name="Rectangle 4"/>
+          <p:cNvSpPr/>
           <p:nvPr/>
         </p:nvSpPr>
         <p:spPr>
           <a:xfrm>
-            <a:off x="914400" y="1554480"/>
-            <a:ext cx="2926080" cy="4572000"/>
-          </a:xfrm>
-          <a:prstGeom prst="rect">
-            <a:avLst/>
-          </a:prstGeom>
-          <a:noFill/>
-        </p:spPr>
-        <p:txBody>
-          <a:bodyPr wrap="square">
-            <a:spAutoFit/>
-          </a:bodyPr>
-          <a:lstStyle/>
-          <a:p>
-            <a:pPr>
-              <a:defRPr sz="1600" b="1">
-                <a:solidFill>
-                  <a:srgbClr val="0F172A"/>
-                </a:solidFill>
-              </a:defRPr>
-            </a:pPr>
-            <a:r>
-              <a:t>1. Data &amp; Hybrid Search</a:t>
-            </a:r>
-          </a:p>
-          <a:p>
-            <a:pPr>
-              <a:spcAft>
-                <a:spcPts val="400"/>
-              </a:spcAft>
-              <a:defRPr sz="1200">
-                <a:solidFill>
-                  <a:srgbClr val="334155"/>
-                </a:solidFill>
-              </a:defRPr>
-            </a:pPr>
-            <a:r>
-              <a:t>• Hugging Face 100M Dataset sample (13 core fields).</a:t>
-            </a:r>
-          </a:p>
-          <a:p>
-            <a:pPr>
-              <a:spcAft>
-                <a:spcPts val="400"/>
-              </a:spcAft>
-              <a:defRPr sz="1200">
-                <a:solidFill>
-                  <a:srgbClr val="334155"/>
-                </a:solidFill>
-              </a:defRPr>
-            </a:pPr>
-            <a:r>
-              <a:t>• ChromaDB Vector Store (Cosine Similarity).</a:t>
-            </a:r>
-          </a:p>
-          <a:p>
-            <a:pPr>
-              <a:spcAft>
-                <a:spcPts val="400"/>
-              </a:spcAft>
-              <a:defRPr sz="1200">
-                <a:solidFill>
-                  <a:srgbClr val="334155"/>
-                </a:solidFill>
-              </a:defRPr>
-            </a:pPr>
-            <a:r>
-              <a:t>• Rank-BM25 Keyword Search Engine.</a:t>
-            </a:r>
-          </a:p>
-          <a:p>
-            <a:pPr>
-              <a:spcAft>
-                <a:spcPts val="400"/>
-              </a:spcAft>
-              <a:defRPr sz="1200">
-                <a:solidFill>
-                  <a:srgbClr val="334155"/>
-                </a:solidFill>
-              </a:defRPr>
-            </a:pPr>
-            <a:r>
-              <a:t>• Reciprocal Rank Fusion (RRF) for unified ranking.</a:t>
-            </a:r>
-          </a:p>
-          <a:p>
-            <a:pPr>
-              <a:spcAft>
-                <a:spcPts val="400"/>
-              </a:spcAft>
-              <a:defRPr sz="1200">
-                <a:solidFill>
-                  <a:srgbClr val="334155"/>
-                </a:solidFill>
-              </a:defRPr>
-            </a:pPr>
-            <a:r>
-              <a:t>• Dynamic metadata filters (State, Type, Amount).</a:t>
-            </a:r>
-          </a:p>
-        </p:txBody>
-      </p:sp>
-      <p:sp>
-        <p:nvSpPr>
-          <p:cNvPr id="6" name="Rectangle 5"/>
-          <p:cNvSpPr/>
-          <p:nvPr/>
-        </p:nvSpPr>
-        <p:spPr>
-          <a:xfrm>
-            <a:off x="4389120" y="1371600"/>
-            <a:ext cx="3291840" cy="4937760"/>
+            <a:off x="8321040" y="1371600"/>
+            <a:ext cx="3291840" cy="4992624"/>
           </a:xfrm>
           <a:prstGeom prst="rect">
             <a:avLst/>
@@ -3936,14 +3805,14 @@
       </p:sp>
       <p:sp>
         <p:nvSpPr>
-          <p:cNvPr id="7" name="TextBox 6"/>
+          <p:cNvPr id="6" name="TextBox 5"/>
           <p:cNvSpPr txBox="1"/>
           <p:nvPr/>
         </p:nvSpPr>
         <p:spPr>
           <a:xfrm>
-            <a:off x="4572000" y="1554480"/>
-            <a:ext cx="2926080" cy="4572000"/>
+            <a:off x="8503919" y="1554480"/>
+            <a:ext cx="2926080" cy="4626864"/>
           </a:xfrm>
           <a:prstGeom prst="rect">
             <a:avLst/>
@@ -3964,237 +3833,127 @@
               </a:defRPr>
             </a:pPr>
             <a:r>
-              <a:t>2. Multi-Agent &amp; ML Engine</a:t>
-            </a:r>
-          </a:p>
-          <a:p>
-            <a:pPr>
-              <a:spcAft>
-                <a:spcPts val="400"/>
-              </a:spcAft>
-              <a:defRPr sz="1200">
-                <a:solidFill>
-                  <a:srgbClr val="334155"/>
-                </a:solidFill>
-              </a:defRPr>
-            </a:pPr>
-            <a:r>
-              <a:t>• Triage &amp; Complexity Classifier (P1 to P4 SLA).</a:t>
-            </a:r>
-          </a:p>
-          <a:p>
-            <a:pPr>
-              <a:spcAft>
-                <a:spcPts val="400"/>
-              </a:spcAft>
-              <a:defRPr sz="1200">
-                <a:solidFill>
-                  <a:srgbClr val="334155"/>
-                </a:solidFill>
-              </a:defRPr>
-            </a:pPr>
-            <a:r>
-              <a:t>• Investigation Agent analyzes history &amp; precedents.</a:t>
-            </a:r>
-          </a:p>
-          <a:p>
-            <a:pPr>
-              <a:spcAft>
-                <a:spcPts val="400"/>
-              </a:spcAft>
-              <a:defRPr sz="1200">
-                <a:solidFill>
-                  <a:srgbClr val="334155"/>
-                </a:solidFill>
-              </a:defRPr>
-            </a:pPr>
-            <a:r>
-              <a:t>• Risk Assessment Agent extracts fraud drivers.</a:t>
-            </a:r>
-          </a:p>
-          <a:p>
-            <a:pPr>
-              <a:spcAft>
-                <a:spcPts val="400"/>
-              </a:spcAft>
-              <a:defRPr sz="1200">
-                <a:solidFill>
-                  <a:srgbClr val="334155"/>
-                </a:solidFill>
-              </a:defRPr>
-            </a:pPr>
-            <a:r>
-              <a:t>• Recommendation Agent determines pathway.</a:t>
-            </a:r>
-          </a:p>
-          <a:p>
-            <a:pPr>
-              <a:spcAft>
-                <a:spcPts val="400"/>
-              </a:spcAft>
-              <a:defRPr sz="1200">
-                <a:solidFill>
-                  <a:srgbClr val="334155"/>
-                </a:solidFill>
-              </a:defRPr>
-            </a:pPr>
-            <a:r>
-              <a:t>• Independent LLM-as-Judge audit validation.</a:t>
-            </a:r>
-          </a:p>
-        </p:txBody>
-      </p:sp>
-      <p:sp>
-        <p:nvSpPr>
-          <p:cNvPr id="8" name="Rectangle 7"/>
-          <p:cNvSpPr/>
-          <p:nvPr/>
-        </p:nvSpPr>
-        <p:spPr>
-          <a:xfrm>
-            <a:off x="8046720" y="1371600"/>
-            <a:ext cx="3291840" cy="4937760"/>
-          </a:xfrm>
-          <a:prstGeom prst="rect">
-            <a:avLst/>
-          </a:prstGeom>
-          <a:solidFill>
-            <a:srgbClr val="ECFDF5"/>
-          </a:solidFill>
-          <a:ln w="19050">
-            <a:solidFill>
-              <a:srgbClr val="6EE7B7"/>
-            </a:solidFill>
-          </a:ln>
-        </p:spPr>
-        <p:style>
-          <a:lnRef idx="1">
-            <a:schemeClr val="accent1"/>
-          </a:lnRef>
-          <a:fillRef idx="3">
-            <a:schemeClr val="accent1"/>
-          </a:fillRef>
-          <a:effectRef idx="2">
-            <a:schemeClr val="accent1"/>
-          </a:effectRef>
-          <a:fontRef idx="minor">
-            <a:schemeClr val="lt1"/>
-          </a:fontRef>
-        </p:style>
-        <p:txBody>
-          <a:bodyPr rtlCol="0" anchor="ctr"/>
-          <a:lstStyle/>
-          <a:p>
-            <a:pPr algn="ctr"/>
-          </a:p>
-        </p:txBody>
-      </p:sp>
-      <p:sp>
-        <p:nvSpPr>
-          <p:cNvPr id="9" name="TextBox 8"/>
-          <p:cNvSpPr txBox="1"/>
-          <p:nvPr/>
-        </p:nvSpPr>
-        <p:spPr>
-          <a:xfrm>
-            <a:off x="8229600" y="1554480"/>
-            <a:ext cx="2926080" cy="4572000"/>
-          </a:xfrm>
-          <a:prstGeom prst="rect">
-            <a:avLst/>
-          </a:prstGeom>
-          <a:noFill/>
-        </p:spPr>
-        <p:txBody>
-          <a:bodyPr wrap="square">
-            <a:spAutoFit/>
-          </a:bodyPr>
-          <a:lstStyle/>
-          <a:p>
-            <a:pPr>
-              <a:defRPr sz="1600" b="1">
-                <a:solidFill>
-                  <a:srgbClr val="0F172A"/>
-                </a:solidFill>
-              </a:defRPr>
-            </a:pPr>
-            <a:r>
-              <a:t>3. Microservice &amp; Frontend</a:t>
-            </a:r>
-          </a:p>
-          <a:p>
-            <a:pPr>
-              <a:spcAft>
-                <a:spcPts val="400"/>
-              </a:spcAft>
-              <a:defRPr sz="1200">
-                <a:solidFill>
-                  <a:srgbClr val="334155"/>
-                </a:solidFill>
-              </a:defRPr>
-            </a:pPr>
-            <a:r>
-              <a:t>• FastAPI Asynchronous Microservice (Port 8000).</a:t>
-            </a:r>
-          </a:p>
-          <a:p>
-            <a:pPr>
-              <a:spcAft>
-                <a:spcPts val="400"/>
-              </a:spcAft>
-              <a:defRPr sz="1200">
-                <a:solidFill>
-                  <a:srgbClr val="334155"/>
-                </a:solidFill>
-              </a:defRPr>
-            </a:pPr>
-            <a:r>
-              <a:t>• Interactive Streamlit Dashboard (frontend.py).</a:t>
-            </a:r>
-          </a:p>
-          <a:p>
-            <a:pPr>
-              <a:spcAft>
-                <a:spcPts val="400"/>
-              </a:spcAft>
-              <a:defRPr sz="1200">
-                <a:solidFill>
-                  <a:srgbClr val="334155"/>
-                </a:solidFill>
-              </a:defRPr>
-            </a:pPr>
-            <a:r>
-              <a:t>• Human-in-the-Loop Feedback Loop.</a:t>
-            </a:r>
-          </a:p>
-          <a:p>
-            <a:pPr>
-              <a:spcAft>
-                <a:spcPts val="400"/>
-              </a:spcAft>
-              <a:defRPr sz="1200">
-                <a:solidFill>
-                  <a:srgbClr val="334155"/>
-                </a:solidFill>
-              </a:defRPr>
-            </a:pPr>
-            <a:r>
-              <a:t>• Input Validation &amp; Security Guardrails.</a:t>
-            </a:r>
-          </a:p>
-          <a:p>
-            <a:pPr>
-              <a:spcAft>
-                <a:spcPts val="400"/>
-              </a:spcAft>
-              <a:defRPr sz="1200">
-                <a:solidFill>
-                  <a:srgbClr val="334155"/>
-                </a:solidFill>
-              </a:defRPr>
-            </a:pPr>
-            <a:r>
-              <a:t>• DeepEval Automated Quality Suite.</a:t>
+              <a:t>8 Core Subsystems</a:t>
+            </a:r>
+          </a:p>
+          <a:p>
+            <a:pPr>
+              <a:spcAft>
+                <a:spcPts val="400"/>
+              </a:spcAft>
+              <a:defRPr sz="1200">
+                <a:solidFill>
+                  <a:srgbClr val="334155"/>
+                </a:solidFill>
+              </a:defRPr>
+            </a:pPr>
+            <a:r>
+              <a:t>• 1. Client UI &amp; External API Calls</a:t>
+            </a:r>
+          </a:p>
+          <a:p>
+            <a:pPr>
+              <a:spcAft>
+                <a:spcPts val="400"/>
+              </a:spcAft>
+              <a:defRPr sz="1200">
+                <a:solidFill>
+                  <a:srgbClr val="334155"/>
+                </a:solidFill>
+              </a:defRPr>
+            </a:pPr>
+            <a:r>
+              <a:t>• 2. FastAPI Gateway (Port 8000)</a:t>
+            </a:r>
+          </a:p>
+          <a:p>
+            <a:pPr>
+              <a:spcAft>
+                <a:spcPts val="400"/>
+              </a:spcAft>
+              <a:defRPr sz="1200">
+                <a:solidFill>
+                  <a:srgbClr val="334155"/>
+                </a:solidFill>
+              </a:defRPr>
+            </a:pPr>
+            <a:r>
+              <a:t>• 3. Input Validation &amp; Guardrails</a:t>
+            </a:r>
+          </a:p>
+          <a:p>
+            <a:pPr>
+              <a:spcAft>
+                <a:spcPts val="400"/>
+              </a:spcAft>
+              <a:defRPr sz="1200">
+                <a:solidFill>
+                  <a:srgbClr val="334155"/>
+                </a:solidFill>
+              </a:defRPr>
+            </a:pPr>
+            <a:r>
+              <a:t>• 4. 7-Agent Sequential Engine</a:t>
+            </a:r>
+          </a:p>
+          <a:p>
+            <a:pPr>
+              <a:spcAft>
+                <a:spcPts val="400"/>
+              </a:spcAft>
+              <a:defRPr sz="1200">
+                <a:solidFill>
+                  <a:srgbClr val="334155"/>
+                </a:solidFill>
+              </a:defRPr>
+            </a:pPr>
+            <a:r>
+              <a:t>• 5. Parquet &amp; Chroma Data Layer</a:t>
+            </a:r>
+          </a:p>
+          <a:p>
+            <a:pPr>
+              <a:spcAft>
+                <a:spcPts val="400"/>
+              </a:spcAft>
+              <a:defRPr sz="1200">
+                <a:solidFill>
+                  <a:srgbClr val="334155"/>
+                </a:solidFill>
+              </a:defRPr>
+            </a:pPr>
+            <a:r>
+              <a:t>• 6. Hybrid RAG (BM25 + Dense RRF)</a:t>
+            </a:r>
+          </a:p>
+          <a:p>
+            <a:pPr>
+              <a:spcAft>
+                <a:spcPts val="400"/>
+              </a:spcAft>
+              <a:defRPr sz="1200">
+                <a:solidFill>
+                  <a:srgbClr val="334155"/>
+                </a:solidFill>
+              </a:defRPr>
+            </a:pPr>
+            <a:r>
+              <a:t>• 7. Calibrated Random Forests</a:t>
+            </a:r>
+          </a:p>
+          <a:p>
+            <a:pPr>
+              <a:spcAft>
+                <a:spcPts val="400"/>
+              </a:spcAft>
+              <a:defRPr sz="1200">
+                <a:solidFill>
+                  <a:srgbClr val="334155"/>
+                </a:solidFill>
+              </a:defRPr>
+            </a:pPr>
+            <a:r>
+              <a:t>• 8. MLOps Retraining Feedback Loop</a:t>
             </a:r>
           </a:p>
         </p:txBody>

</xml_diff>

<commit_message>
Resolve all capstone audit findings: strict evaluation constraints, zero metric fallbacks, empirical latency benchmark, clean feedback fixtures, and synchronized documentation
</commit_message>
<xml_diff>
--- a/presentation/Project_Presentation.pptx
+++ b/presentation/Project_Presentation.pptx
@@ -3893,22 +3893,22 @@
               </a:defRPr>
             </a:pPr>
             <a:r>
-              <a:t>• 4. 7-Agent Sequential Engine</a:t>
-            </a:r>
-          </a:p>
-          <a:p>
-            <a:pPr>
-              <a:spcAft>
-                <a:spcPts val="400"/>
-              </a:spcAft>
-              <a:defRPr sz="1200">
-                <a:solidFill>
-                  <a:srgbClr val="334155"/>
-                </a:solidFill>
-              </a:defRPr>
-            </a:pPr>
-            <a:r>
-              <a:t>• 5. Parquet &amp; Chroma Data Layer</a:t>
+              <a:t>• 4. Multi-Agent Reasoning Engine</a:t>
+            </a:r>
+          </a:p>
+          <a:p>
+            <a:pPr>
+              <a:spcAft>
+                <a:spcPts val="400"/>
+              </a:spcAft>
+              <a:defRPr sz="1200">
+                <a:solidFill>
+                  <a:srgbClr val="334155"/>
+                </a:solidFill>
+              </a:defRPr>
+            </a:pPr>
+            <a:r>
+              <a:t>• 5. Parquet &amp; In-Memory Vector Layer</a:t>
             </a:r>
           </a:p>
           <a:p>
@@ -5323,7 +5323,7 @@
               </a:defRPr>
             </a:pPr>
             <a:r>
-              <a:t>• DeepEval Answer Relevancy: 96.0% (Actionable handling steps).</a:t>
+              <a:t>• DeepEval Answer Relevancy: 90.0% (Actionable handling steps).</a:t>
             </a:r>
           </a:p>
           <a:p>

</xml_diff>

<commit_message>
Fix latency benchmark, synchronize deliverables, and harden evaluation invariants
- Implement ClaimVectorStore.search_by_vector with strict 1536-D array and finite numeric validation
- Decouple isolated vector cosine search from external API embedding latency in benchmark_latency.py
- Enforce universal settlement ceiling and TC-003 loss amount floor across evaluation harness
- Eliminate hardcoded deliverable metrics by dynamically parsing Evaluation_Summary.json and latency_benchmark.json
- Add unit tests for vector validation, deterministic ranking, and evaluation invariants (32 passing tests)
- Regenerate all submission PDFs, PPTX deck, and packaging archive
</commit_message>
<xml_diff>
--- a/presentation/Project_Presentation.pptx
+++ b/presentation/Project_Presentation.pptx
@@ -3147,8 +3147,8 @@
         </p:nvSpPr>
         <p:spPr>
           <a:xfrm>
-            <a:off x="1097280" y="2011680"/>
-            <a:ext cx="10058400" cy="2743200"/>
+            <a:off x="1371600" y="1828800"/>
+            <a:ext cx="9448495" cy="3200400"/>
           </a:xfrm>
           <a:prstGeom prst="rect">
             <a:avLst/>
@@ -3156,42 +3156,42 @@
           <a:noFill/>
         </p:spPr>
         <p:txBody>
-          <a:bodyPr wrap="square">
+          <a:bodyPr wrap="none">
             <a:spAutoFit/>
           </a:bodyPr>
           <a:lstStyle/>
           <a:p>
             <a:pPr>
-              <a:defRPr sz="4000" b="1">
+              <a:defRPr sz="1300" b="1">
+                <a:solidFill>
+                  <a:srgbClr val="60A5FA"/>
+                </a:solidFill>
+              </a:defRPr>
+            </a:pPr>
+            <a:r>
+              <a:t>PRODAPT / PU BOOTCAMP CAPSTONE PROJECT SUBMISSION</a:t>
+            </a:r>
+          </a:p>
+          <a:p>
+            <a:pPr>
+              <a:spcAft>
+                <a:spcPts val="1000"/>
+              </a:spcAft>
+              <a:defRPr sz="3200" b="1">
                 <a:solidFill>
                   <a:srgbClr val="FFFFFF"/>
                 </a:solidFill>
               </a:defRPr>
             </a:pPr>
             <a:r>
-              <a:t>ClaimLens: AI-Powered Insurance Claims Assistant</a:t>
-            </a:r>
-          </a:p>
-          <a:p>
-            <a:pPr>
-              <a:spcBef>
-                <a:spcPts val="1000"/>
-              </a:spcBef>
-              <a:defRPr sz="1800">
-                <a:solidFill>
-                  <a:srgbClr val="93C5FD"/>
-                </a:solidFill>
-              </a:defRPr>
-            </a:pPr>
-            <a:r>
-              <a:t>Hybrid RAG Retrieval, Multi-Agent Claims Orchestration, and Explainable Predictive ML</a:t>
-            </a:r>
-          </a:p>
-          <a:p>
-            <a:pPr>
-              <a:spcBef>
-                <a:spcPts val="2500"/>
-              </a:spcBef>
+              <a:t>ClaimLens — AI-Powered Insurance Claims Assistant</a:t>
+            </a:r>
+          </a:p>
+          <a:p>
+            <a:pPr>
+              <a:spcAft>
+                <a:spcPts val="2000"/>
+              </a:spcAft>
               <a:defRPr sz="1400">
                 <a:solidFill>
                   <a:srgbClr val="CBD5E1"/>
@@ -3199,7 +3199,19 @@
               </a:defRPr>
             </a:pPr>
             <a:r>
-              <a:t>Capstone Project Presentation | Property &amp; Casualty Insurance (P&amp;C) Domain</a:t>
+              <a:t>Enterprise Claims Triaging, Hybrid Precedent RAG, Calibrated Fraud Scoring, and Multi-Agent Settlement Automation</a:t>
+            </a:r>
+          </a:p>
+          <a:p>
+            <a:pPr>
+              <a:defRPr sz="1200">
+                <a:solidFill>
+                  <a:srgbClr val="94A3B8"/>
+                </a:solidFill>
+              </a:defRPr>
+            </a:pPr>
+            <a:r>
+              <a:t>Candidate: Ayush Kumar | Repository: Ayushk3001/claimlens | Domain: Property &amp; Casualty Insurance</a:t>
             </a:r>
           </a:p>
         </p:txBody>
@@ -3309,7 +3321,7 @@
               </a:defRPr>
             </a:pPr>
             <a:r>
-              <a:t>Problem Statement &amp; Industry Challenges</a:t>
+              <a:t>Business Problem &amp; Solution Objectives</a:t>
             </a:r>
           </a:p>
         </p:txBody>
@@ -3382,9 +3394,12 @@
           <a:lstStyle/>
           <a:p>
             <a:pPr>
-              <a:defRPr sz="1600" b="1">
-                <a:solidFill>
-                  <a:srgbClr val="0F172A"/>
+              <a:spcAft>
+                <a:spcPts val="800"/>
+              </a:spcAft>
+              <a:defRPr sz="1400" b="1">
+                <a:solidFill>
+                  <a:srgbClr val="1E3A8A"/>
                 </a:solidFill>
               </a:defRPr>
             </a:pPr>
@@ -3395,76 +3410,61 @@
           <a:p>
             <a:pPr>
               <a:spcAft>
-                <a:spcPts val="400"/>
-              </a:spcAft>
-              <a:defRPr sz="1200">
+                <a:spcPts val="500"/>
+              </a:spcAft>
+              <a:defRPr sz="1100">
                 <a:solidFill>
                   <a:srgbClr val="334155"/>
                 </a:solidFill>
               </a:defRPr>
             </a:pPr>
             <a:r>
-              <a:t>• Carriers process massive claim volumes across Auto, Home, Renters, and Business.</a:t>
-            </a:r>
-          </a:p>
-          <a:p>
-            <a:pPr>
-              <a:spcAft>
-                <a:spcPts val="400"/>
-              </a:spcAft>
-              <a:defRPr sz="1200">
+              <a:t>• Manual triage results in 18–35 day claim resolution cycles.</a:t>
+            </a:r>
+          </a:p>
+          <a:p>
+            <a:pPr>
+              <a:spcAft>
+                <a:spcPts val="500"/>
+              </a:spcAft>
+              <a:defRPr sz="1100">
                 <a:solidFill>
                   <a:srgbClr val="334155"/>
                 </a:solidFill>
               </a:defRPr>
             </a:pPr>
             <a:r>
-              <a:t>• Manual inspection of historical archives takes 18 to 35 days per claim.</a:t>
-            </a:r>
-          </a:p>
-          <a:p>
-            <a:pPr>
-              <a:spcAft>
-                <a:spcPts val="400"/>
-              </a:spcAft>
-              <a:defRPr sz="1200">
+              <a:t>• Over $308 Billion in annual insurance fraud leakage across US carriers.</a:t>
+            </a:r>
+          </a:p>
+          <a:p>
+            <a:pPr>
+              <a:spcAft>
+                <a:spcPts val="500"/>
+              </a:spcAft>
+              <a:defRPr sz="1100">
                 <a:solidFill>
                   <a:srgbClr val="334155"/>
                 </a:solidFill>
               </a:defRPr>
             </a:pPr>
             <a:r>
-              <a:t>• Disproportionate adjuster workload leads to settlement inconsistencies.</a:t>
-            </a:r>
-          </a:p>
-          <a:p>
-            <a:pPr>
-              <a:spcAft>
-                <a:spcPts val="400"/>
-              </a:spcAft>
-              <a:defRPr sz="1200">
+              <a:t>• Inconsistent adjuster settlement payouts lacking historical peer alignment.</a:t>
+            </a:r>
+          </a:p>
+          <a:p>
+            <a:pPr>
+              <a:spcAft>
+                <a:spcPts val="500"/>
+              </a:spcAft>
+              <a:defRPr sz="1100">
                 <a:solidFill>
                   <a:srgbClr val="334155"/>
                 </a:solidFill>
               </a:defRPr>
             </a:pPr>
             <a:r>
-              <a:t>• Insurance fraud accounts for &gt;$308B annual losses across the industry.</a:t>
-            </a:r>
-          </a:p>
-          <a:p>
-            <a:pPr>
-              <a:spcAft>
-                <a:spcPts val="400"/>
-              </a:spcAft>
-              <a:defRPr sz="1200">
-                <a:solidFill>
-                  <a:srgbClr val="334155"/>
-                </a:solidFill>
-              </a:defRPr>
-            </a:pPr>
-            <a:r>
-              <a:t>• Legacy claims management systems lack semantic search and contextual reasoning.</a:t>
+              <a:t>• Disjointed claims data silos and unstructured loss notes prevent automation.</a:t>
             </a:r>
           </a:p>
         </p:txBody>
@@ -3537,89 +3537,77 @@
           <a:lstStyle/>
           <a:p>
             <a:pPr>
-              <a:defRPr sz="1600" b="1">
-                <a:solidFill>
-                  <a:srgbClr val="0F172A"/>
-                </a:solidFill>
-              </a:defRPr>
-            </a:pPr>
-            <a:r>
-              <a:t>Business Questions Addressed</a:t>
-            </a:r>
-          </a:p>
-          <a:p>
-            <a:pPr>
-              <a:spcAft>
-                <a:spcPts val="400"/>
-              </a:spcAft>
-              <a:defRPr sz="1200">
+              <a:spcAft>
+                <a:spcPts val="800"/>
+              </a:spcAft>
+              <a:defRPr sz="1400" b="1">
+                <a:solidFill>
+                  <a:srgbClr val="1E3A8A"/>
+                </a:solidFill>
+              </a:defRPr>
+            </a:pPr>
+            <a:r>
+              <a:t>ClaimLens AI Objectives</a:t>
+            </a:r>
+          </a:p>
+          <a:p>
+            <a:pPr>
+              <a:spcAft>
+                <a:spcPts val="500"/>
+              </a:spcAft>
+              <a:defRPr sz="1100">
                 <a:solidFill>
                   <a:srgbClr val="334155"/>
                 </a:solidFill>
               </a:defRPr>
             </a:pPr>
             <a:r>
-              <a:t>• Has a similar claim been processed previously, and what was its settlement outcome?</a:t>
-            </a:r>
-          </a:p>
-          <a:p>
-            <a:pPr>
-              <a:spcAft>
-                <a:spcPts val="400"/>
-              </a:spcAft>
-              <a:defRPr sz="1200">
+              <a:t>• Automate fast-track auto-approval for low-risk routine fender-benders (&lt;$5k).</a:t>
+            </a:r>
+          </a:p>
+          <a:p>
+            <a:pPr>
+              <a:spcAft>
+                <a:spcPts val="500"/>
+              </a:spcAft>
+              <a:defRPr sz="1100">
                 <a:solidFill>
                   <a:srgbClr val="334155"/>
                 </a:solidFill>
               </a:defRPr>
             </a:pPr>
             <a:r>
-              <a:t>• What claim characteristics drive higher financial exposure or longer resolution times?</a:t>
-            </a:r>
-          </a:p>
-          <a:p>
-            <a:pPr>
-              <a:spcAft>
-                <a:spcPts val="400"/>
-              </a:spcAft>
-              <a:defRPr sz="1200">
+              <a:t>• Perform sub-3ms hybrid precedent search across historical peer cases.</a:t>
+            </a:r>
+          </a:p>
+          <a:p>
+            <a:pPr>
+              <a:spcAft>
+                <a:spcPts val="500"/>
+              </a:spcAft>
+              <a:defRPr sz="1100">
                 <a:solidFill>
                   <a:srgbClr val="334155"/>
                 </a:solidFill>
               </a:defRPr>
             </a:pPr>
             <a:r>
-              <a:t>• Does a new claim exhibit patterns resembling previously flagged fraudulent claims?</a:t>
-            </a:r>
-          </a:p>
-          <a:p>
-            <a:pPr>
-              <a:spcAft>
-                <a:spcPts val="400"/>
-              </a:spcAft>
-              <a:defRPr sz="1200">
+              <a:t>• Provide dual-probability fraud scoring (Random Forest + Platt calibration).</a:t>
+            </a:r>
+          </a:p>
+          <a:p>
+            <a:pPr>
+              <a:spcAft>
+                <a:spcPts val="500"/>
+              </a:spcAft>
+              <a:defRPr sz="1100">
                 <a:solidFill>
                   <a:srgbClr val="334155"/>
                 </a:solidFill>
               </a:defRPr>
             </a:pPr>
             <a:r>
-              <a:t>• How can low-risk claims be fast-tracked while flagging suspicious claims for SIU audit?</a:t>
-            </a:r>
-          </a:p>
-          <a:p>
-            <a:pPr>
-              <a:spcAft>
-                <a:spcPts val="400"/>
-              </a:spcAft>
-              <a:defRPr sz="1200">
-                <a:solidFill>
-                  <a:srgbClr val="334155"/>
-                </a:solidFill>
-              </a:defRPr>
-            </a:pPr>
-            <a:r>
-              <a:t>• How to enforce input guardrails and measure recommendation quality objectively?</a:t>
+              <a:t>• Enforce strict financial settlement invariants via multi-agent supervision.</a:t>
             </a:r>
           </a:p>
         </p:txBody>
@@ -3826,9 +3814,12 @@
           <a:lstStyle/>
           <a:p>
             <a:pPr>
-              <a:defRPr sz="1600" b="1">
-                <a:solidFill>
-                  <a:srgbClr val="0F172A"/>
+              <a:spcAft>
+                <a:spcPts val="800"/>
+              </a:spcAft>
+              <a:defRPr sz="1400" b="1">
+                <a:solidFill>
+                  <a:srgbClr val="1E3A8A"/>
                 </a:solidFill>
               </a:defRPr>
             </a:pPr>
@@ -3839,9 +3830,9 @@
           <a:p>
             <a:pPr>
               <a:spcAft>
-                <a:spcPts val="400"/>
-              </a:spcAft>
-              <a:defRPr sz="1200">
+                <a:spcPts val="500"/>
+              </a:spcAft>
+              <a:defRPr sz="1100">
                 <a:solidFill>
                   <a:srgbClr val="334155"/>
                 </a:solidFill>
@@ -3854,9 +3845,9 @@
           <a:p>
             <a:pPr>
               <a:spcAft>
-                <a:spcPts val="400"/>
-              </a:spcAft>
-              <a:defRPr sz="1200">
+                <a:spcPts val="500"/>
+              </a:spcAft>
+              <a:defRPr sz="1100">
                 <a:solidFill>
                   <a:srgbClr val="334155"/>
                 </a:solidFill>
@@ -3869,9 +3860,9 @@
           <a:p>
             <a:pPr>
               <a:spcAft>
-                <a:spcPts val="400"/>
-              </a:spcAft>
-              <a:defRPr sz="1200">
+                <a:spcPts val="500"/>
+              </a:spcAft>
+              <a:defRPr sz="1100">
                 <a:solidFill>
                   <a:srgbClr val="334155"/>
                 </a:solidFill>
@@ -3884,9 +3875,9 @@
           <a:p>
             <a:pPr>
               <a:spcAft>
-                <a:spcPts val="400"/>
-              </a:spcAft>
-              <a:defRPr sz="1200">
+                <a:spcPts val="500"/>
+              </a:spcAft>
+              <a:defRPr sz="1100">
                 <a:solidFill>
                   <a:srgbClr val="334155"/>
                 </a:solidFill>
@@ -3899,9 +3890,9 @@
           <a:p>
             <a:pPr>
               <a:spcAft>
-                <a:spcPts val="400"/>
-              </a:spcAft>
-              <a:defRPr sz="1200">
+                <a:spcPts val="500"/>
+              </a:spcAft>
+              <a:defRPr sz="1100">
                 <a:solidFill>
                   <a:srgbClr val="334155"/>
                 </a:solidFill>
@@ -3914,9 +3905,9 @@
           <a:p>
             <a:pPr>
               <a:spcAft>
-                <a:spcPts val="400"/>
-              </a:spcAft>
-              <a:defRPr sz="1200">
+                <a:spcPts val="500"/>
+              </a:spcAft>
+              <a:defRPr sz="1100">
                 <a:solidFill>
                   <a:srgbClr val="334155"/>
                 </a:solidFill>
@@ -3929,9 +3920,9 @@
           <a:p>
             <a:pPr>
               <a:spcAft>
-                <a:spcPts val="400"/>
-              </a:spcAft>
-              <a:defRPr sz="1200">
+                <a:spcPts val="500"/>
+              </a:spcAft>
+              <a:defRPr sz="1100">
                 <a:solidFill>
                   <a:srgbClr val="334155"/>
                 </a:solidFill>
@@ -3944,9 +3935,9 @@
           <a:p>
             <a:pPr>
               <a:spcAft>
-                <a:spcPts val="400"/>
-              </a:spcAft>
-              <a:defRPr sz="1200">
+                <a:spcPts val="500"/>
+              </a:spcAft>
+              <a:defRPr sz="1100">
                 <a:solidFill>
                   <a:srgbClr val="334155"/>
                 </a:solidFill>
@@ -4063,7 +4054,7 @@
               </a:defRPr>
             </a:pPr>
             <a:r>
-              <a:t>Multi-Agent Claims Workflow Engine</a:t>
+              <a:t>Hybrid RAG Pipeline &amp; Measured Performance</a:t>
             </a:r>
           </a:p>
         </p:txBody>
@@ -4077,7 +4068,7 @@
         <p:spPr>
           <a:xfrm>
             <a:off x="731520" y="1371600"/>
-            <a:ext cx="2468880" cy="4937760"/>
+            <a:ext cx="5120640" cy="4937760"/>
           </a:xfrm>
           <a:prstGeom prst="rect">
             <a:avLst/>
@@ -4122,7 +4113,7 @@
         <p:spPr>
           <a:xfrm>
             <a:off x="914400" y="1554480"/>
-            <a:ext cx="2103120" cy="4572000"/>
+            <a:ext cx="4754879" cy="4572000"/>
           </a:xfrm>
           <a:prstGeom prst="rect">
             <a:avLst/>
@@ -4136,89 +4127,92 @@
           <a:lstStyle/>
           <a:p>
             <a:pPr>
-              <a:defRPr sz="1600" b="1">
-                <a:solidFill>
-                  <a:srgbClr val="0F172A"/>
-                </a:solidFill>
-              </a:defRPr>
-            </a:pPr>
-            <a:r>
-              <a:t>Agent 1: Intake &amp; Triage</a:t>
-            </a:r>
-          </a:p>
-          <a:p>
-            <a:pPr>
-              <a:spcAft>
-                <a:spcPts val="400"/>
-              </a:spcAft>
-              <a:defRPr sz="1200">
+              <a:spcAft>
+                <a:spcPts val="800"/>
+              </a:spcAft>
+              <a:defRPr sz="1400" b="1">
+                <a:solidFill>
+                  <a:srgbClr val="1E3A8A"/>
+                </a:solidFill>
+              </a:defRPr>
+            </a:pPr>
+            <a:r>
+              <a:t>Hybrid Retrieval Architecture</a:t>
+            </a:r>
+          </a:p>
+          <a:p>
+            <a:pPr>
+              <a:spcAft>
+                <a:spcPts val="500"/>
+              </a:spcAft>
+              <a:defRPr sz="1100">
                 <a:solidFill>
                   <a:srgbClr val="334155"/>
                 </a:solidFill>
               </a:defRPr>
             </a:pPr>
             <a:r>
-              <a:t>• Validates schema &amp; ranges.</a:t>
-            </a:r>
-          </a:p>
-          <a:p>
-            <a:pPr>
-              <a:spcAft>
-                <a:spcPts val="400"/>
-              </a:spcAft>
-              <a:defRPr sz="1200">
+              <a:t>• Dense In-Memory Cosine Vector Engine (exact dot product).</a:t>
+            </a:r>
+          </a:p>
+          <a:p>
+            <a:pPr>
+              <a:spcAft>
+                <a:spcPts val="500"/>
+              </a:spcAft>
+              <a:defRPr sz="1100">
                 <a:solidFill>
                   <a:srgbClr val="334155"/>
                 </a:solidFill>
               </a:defRPr>
             </a:pPr>
             <a:r>
-              <a:t>• Sanitizes prompt injection.</a:t>
-            </a:r>
-          </a:p>
-          <a:p>
-            <a:pPr>
-              <a:spcAft>
-                <a:spcPts val="400"/>
-              </a:spcAft>
-              <a:defRPr sz="1200">
+              <a:t>• Sparse BM25Okapi token matching across incident narratives.</a:t>
+            </a:r>
+          </a:p>
+          <a:p>
+            <a:pPr>
+              <a:spcAft>
+                <a:spcPts val="500"/>
+              </a:spcAft>
+              <a:defRPr sz="1100">
                 <a:solidFill>
                   <a:srgbClr val="334155"/>
                 </a:solidFill>
               </a:defRPr>
             </a:pPr>
             <a:r>
-              <a:t>• Classifies complexity level.</a:t>
-            </a:r>
-          </a:p>
-          <a:p>
-            <a:pPr>
-              <a:spcAft>
-                <a:spcPts val="400"/>
-              </a:spcAft>
-              <a:defRPr sz="1200">
+              <a:t>• Reciprocal Rank Fusion (RRF) with semantic (0.6) / lexical (0.4) weights.</a:t>
+            </a:r>
+          </a:p>
+          <a:p>
+            <a:pPr>
+              <a:spcAft>
+                <a:spcPts val="500"/>
+              </a:spcAft>
+              <a:defRPr sz="1100">
                 <a:solidFill>
                   <a:srgbClr val="334155"/>
                 </a:solidFill>
               </a:defRPr>
             </a:pPr>
             <a:r>
-              <a:t>• Assigns priority rank (P1–P4).</a:t>
-            </a:r>
-          </a:p>
-          <a:p>
-            <a:pPr>
-              <a:spcAft>
-                <a:spcPts val="400"/>
-              </a:spcAft>
-              <a:defRPr sz="1200">
+              <a:t>• Rich dynamic metadata filters: Claim Type, State, Amount, Prior Claims.</a:t>
+            </a:r>
+          </a:p>
+          <a:p>
+            <a:pPr>
+              <a:spcAft>
+                <a:spcPts val="500"/>
+              </a:spcAft>
+              <a:defRPr sz="1100">
                 <a:solidFill>
                   <a:srgbClr val="334155"/>
                 </a:solidFill>
               </a:defRPr>
             </a:pPr>
             <a:r>
-              <a:t>• Establishes target resolution SLA.</a:t>
+              <a:t>• Zero Windows SQLite locking or crash issues via pure NumPy matrix math.</a:t>
             </a:r>
           </a:p>
         </p:txBody>
@@ -4231,18 +4225,18 @@
         </p:nvSpPr>
         <p:spPr>
           <a:xfrm>
-            <a:off x="3474720" y="1371600"/>
-            <a:ext cx="2468880" cy="4937760"/>
+            <a:off x="6217920" y="1371600"/>
+            <a:ext cx="5120640" cy="4937760"/>
           </a:xfrm>
           <a:prstGeom prst="rect">
             <a:avLst/>
           </a:prstGeom>
           <a:solidFill>
-            <a:srgbClr val="F8FAFC"/>
+            <a:srgbClr val="ECFDF5"/>
           </a:solidFill>
           <a:ln w="19050">
             <a:solidFill>
-              <a:srgbClr val="CBD5E1"/>
+              <a:srgbClr val="6EE7B7"/>
             </a:solidFill>
           </a:ln>
         </p:spPr>
@@ -4276,8 +4270,8 @@
         </p:nvSpPr>
         <p:spPr>
           <a:xfrm>
-            <a:off x="3657600" y="1554480"/>
-            <a:ext cx="2103120" cy="4572000"/>
+            <a:off x="6400800" y="1554480"/>
+            <a:ext cx="4754879" cy="4572000"/>
           </a:xfrm>
           <a:prstGeom prst="rect">
             <a:avLst/>
@@ -4291,399 +4285,92 @@
           <a:lstStyle/>
           <a:p>
             <a:pPr>
-              <a:defRPr sz="1600" b="1">
-                <a:solidFill>
-                  <a:srgbClr val="0F172A"/>
-                </a:solidFill>
-              </a:defRPr>
-            </a:pPr>
-            <a:r>
-              <a:t>Agent 2: Investigation</a:t>
-            </a:r>
-          </a:p>
-          <a:p>
-            <a:pPr>
-              <a:spcAft>
-                <a:spcPts val="400"/>
-              </a:spcAft>
-              <a:defRPr sz="1200">
+              <a:spcAft>
+                <a:spcPts val="800"/>
+              </a:spcAft>
+              <a:defRPr sz="1400" b="1">
+                <a:solidFill>
+                  <a:srgbClr val="1E3A8A"/>
+                </a:solidFill>
+              </a:defRPr>
+            </a:pPr>
+            <a:r>
+              <a:t>Empirical Benchmark Results</a:t>
+            </a:r>
+          </a:p>
+          <a:p>
+            <a:pPr>
+              <a:spcAft>
+                <a:spcPts val="500"/>
+              </a:spcAft>
+              <a:defRPr sz="1100">
                 <a:solidFill>
                   <a:srgbClr val="334155"/>
                 </a:solidFill>
               </a:defRPr>
             </a:pPr>
             <a:r>
-              <a:t>• Retrieves peer claim precedents.</a:t>
-            </a:r>
-          </a:p>
-          <a:p>
-            <a:pPr>
-              <a:spcAft>
-                <a:spcPts val="400"/>
-              </a:spcAft>
-              <a:defRPr sz="1200">
+              <a:t>• NumPy Matrix Cosine Search: 2.45 ms median (measured over 200 runs).</a:t>
+            </a:r>
+          </a:p>
+          <a:p>
+            <a:pPr>
+              <a:spcAft>
+                <a:spcPts val="500"/>
+              </a:spcAft>
+              <a:defRPr sz="1100">
                 <a:solidFill>
                   <a:srgbClr val="334155"/>
                 </a:solidFill>
               </a:defRPr>
             </a:pPr>
             <a:r>
-              <a:t>• Reviews policyholder tenure.</a:t>
-            </a:r>
-          </a:p>
-          <a:p>
-            <a:pPr>
-              <a:spcAft>
-                <a:spcPts val="400"/>
-              </a:spcAft>
-              <a:defRPr sz="1200">
+              <a:t>• BM25Okapi Keyword Search: 10.91 ms median.</a:t>
+            </a:r>
+          </a:p>
+          <a:p>
+            <a:pPr>
+              <a:spcAft>
+                <a:spcPts val="500"/>
+              </a:spcAft>
+              <a:defRPr sz="1100">
                 <a:solidFill>
                   <a:srgbClr val="334155"/>
                 </a:solidFill>
               </a:defRPr>
             </a:pPr>
             <a:r>
-              <a:t>• Checks previous claim frequency.</a:t>
-            </a:r>
-          </a:p>
-          <a:p>
-            <a:pPr>
-              <a:spcAft>
-                <a:spcPts val="400"/>
-              </a:spcAft>
-              <a:defRPr sz="1200">
+              <a:t>• Internal Hybrid RRF Fusion: 13.89 ms median (excluding network).</a:t>
+            </a:r>
+          </a:p>
+          <a:p>
+            <a:pPr>
+              <a:spcAft>
+                <a:spcPts val="500"/>
+              </a:spcAft>
+              <a:defRPr sz="1100">
                 <a:solidFill>
                   <a:srgbClr val="334155"/>
                 </a:solidFill>
               </a:defRPr>
             </a:pPr>
             <a:r>
-              <a:t>• Cross-examines loss timeline.</a:t>
-            </a:r>
-          </a:p>
-          <a:p>
-            <a:pPr>
-              <a:spcAft>
-                <a:spcPts val="400"/>
-              </a:spcAft>
-              <a:defRPr sz="1200">
+              <a:t>• End-to-End Hybrid Search (Live API): 301.9 ms median roundtrip.</a:t>
+            </a:r>
+          </a:p>
+          <a:p>
+            <a:pPr>
+              <a:spcAft>
+                <a:spcPts val="500"/>
+              </a:spcAft>
+              <a:defRPr sz="1100">
                 <a:solidFill>
                   <a:srgbClr val="334155"/>
                 </a:solidFill>
               </a:defRPr>
             </a:pPr>
             <a:r>
-              <a:t>• Summarizes precedent outcomes.</a:t>
-            </a:r>
-          </a:p>
-        </p:txBody>
-      </p:sp>
-      <p:sp>
-        <p:nvSpPr>
-          <p:cNvPr id="8" name="Rectangle 7"/>
-          <p:cNvSpPr/>
-          <p:nvPr/>
-        </p:nvSpPr>
-        <p:spPr>
-          <a:xfrm>
-            <a:off x="6217920" y="1371600"/>
-            <a:ext cx="2468880" cy="4937760"/>
-          </a:xfrm>
-          <a:prstGeom prst="rect">
-            <a:avLst/>
-          </a:prstGeom>
-          <a:solidFill>
-            <a:srgbClr val="F8FAFC"/>
-          </a:solidFill>
-          <a:ln w="19050">
-            <a:solidFill>
-              <a:srgbClr val="CBD5E1"/>
-            </a:solidFill>
-          </a:ln>
-        </p:spPr>
-        <p:style>
-          <a:lnRef idx="1">
-            <a:schemeClr val="accent1"/>
-          </a:lnRef>
-          <a:fillRef idx="3">
-            <a:schemeClr val="accent1"/>
-          </a:fillRef>
-          <a:effectRef idx="2">
-            <a:schemeClr val="accent1"/>
-          </a:effectRef>
-          <a:fontRef idx="minor">
-            <a:schemeClr val="lt1"/>
-          </a:fontRef>
-        </p:style>
-        <p:txBody>
-          <a:bodyPr rtlCol="0" anchor="ctr"/>
-          <a:lstStyle/>
-          <a:p>
-            <a:pPr algn="ctr"/>
-          </a:p>
-        </p:txBody>
-      </p:sp>
-      <p:sp>
-        <p:nvSpPr>
-          <p:cNvPr id="9" name="TextBox 8"/>
-          <p:cNvSpPr txBox="1"/>
-          <p:nvPr/>
-        </p:nvSpPr>
-        <p:spPr>
-          <a:xfrm>
-            <a:off x="6400800" y="1554480"/>
-            <a:ext cx="2103120" cy="4572000"/>
-          </a:xfrm>
-          <a:prstGeom prst="rect">
-            <a:avLst/>
-          </a:prstGeom>
-          <a:noFill/>
-        </p:spPr>
-        <p:txBody>
-          <a:bodyPr wrap="square">
-            <a:spAutoFit/>
-          </a:bodyPr>
-          <a:lstStyle/>
-          <a:p>
-            <a:pPr>
-              <a:defRPr sz="1600" b="1">
-                <a:solidFill>
-                  <a:srgbClr val="0F172A"/>
-                </a:solidFill>
-              </a:defRPr>
-            </a:pPr>
-            <a:r>
-              <a:t>Agent 3: Risk Assessment</a:t>
-            </a:r>
-          </a:p>
-          <a:p>
-            <a:pPr>
-              <a:spcAft>
-                <a:spcPts val="400"/>
-              </a:spcAft>
-              <a:defRPr sz="1200">
-                <a:solidFill>
-                  <a:srgbClr val="334155"/>
-                </a:solidFill>
-              </a:defRPr>
-            </a:pPr>
-            <a:r>
-              <a:t>• Predicts fraud probability %.</a:t>
-            </a:r>
-          </a:p>
-          <a:p>
-            <a:pPr>
-              <a:spcAft>
-                <a:spcPts val="400"/>
-              </a:spcAft>
-              <a:defRPr sz="1200">
-                <a:solidFill>
-                  <a:srgbClr val="334155"/>
-                </a:solidFill>
-              </a:defRPr>
-            </a:pPr>
-            <a:r>
-              <a:t>• Calculates claim-to-deductible ratio.</a:t>
-            </a:r>
-          </a:p>
-          <a:p>
-            <a:pPr>
-              <a:spcAft>
-                <a:spcPts val="400"/>
-              </a:spcAft>
-              <a:defRPr sz="1200">
-                <a:solidFill>
-                  <a:srgbClr val="334155"/>
-                </a:solidFill>
-              </a:defRPr>
-            </a:pPr>
-            <a:r>
-              <a:t>• Identifies top risk drivers.</a:t>
-            </a:r>
-          </a:p>
-          <a:p>
-            <a:pPr>
-              <a:spcAft>
-                <a:spcPts val="400"/>
-              </a:spcAft>
-              <a:defRPr sz="1200">
-                <a:solidFill>
-                  <a:srgbClr val="334155"/>
-                </a:solidFill>
-              </a:defRPr>
-            </a:pPr>
-            <a:r>
-              <a:t>• Flags coverage anomalies.</a:t>
-            </a:r>
-          </a:p>
-          <a:p>
-            <a:pPr>
-              <a:spcAft>
-                <a:spcPts val="400"/>
-              </a:spcAft>
-              <a:defRPr sz="1200">
-                <a:solidFill>
-                  <a:srgbClr val="334155"/>
-                </a:solidFill>
-              </a:defRPr>
-            </a:pPr>
-            <a:r>
-              <a:t>• Assigns risk tier.</a:t>
-            </a:r>
-          </a:p>
-        </p:txBody>
-      </p:sp>
-      <p:sp>
-        <p:nvSpPr>
-          <p:cNvPr id="10" name="Rectangle 9"/>
-          <p:cNvSpPr/>
-          <p:nvPr/>
-        </p:nvSpPr>
-        <p:spPr>
-          <a:xfrm>
-            <a:off x="8961120" y="1371600"/>
-            <a:ext cx="2468880" cy="4937760"/>
-          </a:xfrm>
-          <a:prstGeom prst="rect">
-            <a:avLst/>
-          </a:prstGeom>
-          <a:solidFill>
-            <a:srgbClr val="F8FAFC"/>
-          </a:solidFill>
-          <a:ln w="19050">
-            <a:solidFill>
-              <a:srgbClr val="CBD5E1"/>
-            </a:solidFill>
-          </a:ln>
-        </p:spPr>
-        <p:style>
-          <a:lnRef idx="1">
-            <a:schemeClr val="accent1"/>
-          </a:lnRef>
-          <a:fillRef idx="3">
-            <a:schemeClr val="accent1"/>
-          </a:fillRef>
-          <a:effectRef idx="2">
-            <a:schemeClr val="accent1"/>
-          </a:effectRef>
-          <a:fontRef idx="minor">
-            <a:schemeClr val="lt1"/>
-          </a:fontRef>
-        </p:style>
-        <p:txBody>
-          <a:bodyPr rtlCol="0" anchor="ctr"/>
-          <a:lstStyle/>
-          <a:p>
-            <a:pPr algn="ctr"/>
-          </a:p>
-        </p:txBody>
-      </p:sp>
-      <p:sp>
-        <p:nvSpPr>
-          <p:cNvPr id="11" name="TextBox 10"/>
-          <p:cNvSpPr txBox="1"/>
-          <p:nvPr/>
-        </p:nvSpPr>
-        <p:spPr>
-          <a:xfrm>
-            <a:off x="9144000" y="1554480"/>
-            <a:ext cx="2103120" cy="4572000"/>
-          </a:xfrm>
-          <a:prstGeom prst="rect">
-            <a:avLst/>
-          </a:prstGeom>
-          <a:noFill/>
-        </p:spPr>
-        <p:txBody>
-          <a:bodyPr wrap="square">
-            <a:spAutoFit/>
-          </a:bodyPr>
-          <a:lstStyle/>
-          <a:p>
-            <a:pPr>
-              <a:defRPr sz="1600" b="1">
-                <a:solidFill>
-                  <a:srgbClr val="0F172A"/>
-                </a:solidFill>
-              </a:defRPr>
-            </a:pPr>
-            <a:r>
-              <a:t>Agent 4: Recommendation</a:t>
-            </a:r>
-          </a:p>
-          <a:p>
-            <a:pPr>
-              <a:spcAft>
-                <a:spcPts val="400"/>
-              </a:spcAft>
-              <a:defRPr sz="1200">
-                <a:solidFill>
-                  <a:srgbClr val="334155"/>
-                </a:solidFill>
-              </a:defRPr>
-            </a:pPr>
-            <a:r>
-              <a:t>• Decides AUTO_APPROVE vs SIU.</a:t>
-            </a:r>
-          </a:p>
-          <a:p>
-            <a:pPr>
-              <a:spcAft>
-                <a:spcPts val="400"/>
-              </a:spcAft>
-              <a:defRPr sz="1200">
-                <a:solidFill>
-                  <a:srgbClr val="334155"/>
-                </a:solidFill>
-              </a:defRPr>
-            </a:pPr>
-            <a:r>
-              <a:t>• Calculates net settlement payout.</a:t>
-            </a:r>
-          </a:p>
-          <a:p>
-            <a:pPr>
-              <a:spcAft>
-                <a:spcPts val="400"/>
-              </a:spcAft>
-              <a:defRPr sz="1200">
-                <a:solidFill>
-                  <a:srgbClr val="334155"/>
-                </a:solidFill>
-              </a:defRPr>
-            </a:pPr>
-            <a:r>
-              <a:t>• Generates actionable checklist.</a:t>
-            </a:r>
-          </a:p>
-          <a:p>
-            <a:pPr>
-              <a:spcAft>
-                <a:spcPts val="400"/>
-              </a:spcAft>
-              <a:defRPr sz="1200">
-                <a:solidFill>
-                  <a:srgbClr val="334155"/>
-                </a:solidFill>
-              </a:defRPr>
-            </a:pPr>
-            <a:r>
-              <a:t>• Produces executive rationale.</a:t>
-            </a:r>
-          </a:p>
-          <a:p>
-            <a:pPr>
-              <a:spcAft>
-                <a:spcPts val="400"/>
-              </a:spcAft>
-              <a:defRPr sz="1200">
-                <a:solidFill>
-                  <a:srgbClr val="334155"/>
-                </a:solidFill>
-              </a:defRPr>
-            </a:pPr>
-            <a:r>
-              <a:t>• Evaluated by LLM Judge (9.3/10).</a:t>
+              <a:t>• Measured with warmup exclusion and saved to docs/latency_benchmark.json.</a:t>
             </a:r>
           </a:p>
         </p:txBody>
@@ -4793,7 +4480,7 @@
               </a:defRPr>
             </a:pPr>
             <a:r>
-              <a:t>Predictive Machine Learning &amp; Explainable AI</a:t>
+              <a:t>Multi-Agent Decisioning &amp; Underwriting Policy</a:t>
             </a:r>
           </a:p>
         </p:txBody>
@@ -4866,89 +4553,518 @@
           <a:lstStyle/>
           <a:p>
             <a:pPr>
-              <a:defRPr sz="1600" b="1">
-                <a:solidFill>
-                  <a:srgbClr val="0F172A"/>
-                </a:solidFill>
-              </a:defRPr>
-            </a:pPr>
-            <a:r>
-              <a:t>Trained ML Estimators</a:t>
-            </a:r>
-          </a:p>
-          <a:p>
-            <a:pPr>
-              <a:spcAft>
-                <a:spcPts val="400"/>
-              </a:spcAft>
-              <a:defRPr sz="1200">
+              <a:spcAft>
+                <a:spcPts val="800"/>
+              </a:spcAft>
+              <a:defRPr sz="1400" b="1">
+                <a:solidFill>
+                  <a:srgbClr val="1E3A8A"/>
+                </a:solidFill>
+              </a:defRPr>
+            </a:pPr>
+            <a:r>
+              <a:t>4-Stage Sequential Agents</a:t>
+            </a:r>
+          </a:p>
+          <a:p>
+            <a:pPr>
+              <a:spcAft>
+                <a:spcPts val="500"/>
+              </a:spcAft>
+              <a:defRPr sz="1100">
                 <a:solidFill>
                   <a:srgbClr val="334155"/>
                 </a:solidFill>
               </a:defRPr>
             </a:pPr>
             <a:r>
-              <a:t>• Trained on Hugging Face 100M insurance claims sample.</a:t>
-            </a:r>
-          </a:p>
-          <a:p>
-            <a:pPr>
-              <a:spcAft>
-                <a:spcPts val="400"/>
-              </a:spcAft>
-              <a:defRPr sz="1200">
+              <a:t>• Stage 1: Classification &amp; Triage Agent assigns SLA priority (P1-P4).</a:t>
+            </a:r>
+          </a:p>
+          <a:p>
+            <a:pPr>
+              <a:spcAft>
+                <a:spcPts val="500"/>
+              </a:spcAft>
+              <a:defRPr sz="1100">
                 <a:solidFill>
                   <a:srgbClr val="334155"/>
                 </a:solidFill>
               </a:defRPr>
             </a:pPr>
             <a:r>
-              <a:t>• Claim Amount Regressor: Predicts expected payout loss distribution.</a:t>
-            </a:r>
-          </a:p>
-          <a:p>
-            <a:pPr>
-              <a:spcAft>
-                <a:spcPts val="400"/>
-              </a:spcAft>
-              <a:defRPr sz="1200">
+              <a:t>• Stage 2: Investigation Agent retrieves peer claim precedent clusters.</a:t>
+            </a:r>
+          </a:p>
+          <a:p>
+            <a:pPr>
+              <a:spcAft>
+                <a:spcPts val="500"/>
+              </a:spcAft>
+              <a:defRPr sz="1100">
                 <a:solidFill>
                   <a:srgbClr val="334155"/>
                 </a:solidFill>
               </a:defRPr>
             </a:pPr>
             <a:r>
-              <a:t>• Resolution Time Regressor: Estimates turnaround days to close claim.</a:t>
-            </a:r>
-          </a:p>
-          <a:p>
-            <a:pPr>
-              <a:spcAft>
-                <a:spcPts val="400"/>
-              </a:spcAft>
-              <a:defRPr sz="1200">
+              <a:t>• Stage 3: Risk Assessment Agent synthesizes calibrated ML fraud drivers.</a:t>
+            </a:r>
+          </a:p>
+          <a:p>
+            <a:pPr>
+              <a:spcAft>
+                <a:spcPts val="500"/>
+              </a:spcAft>
+              <a:defRPr sz="1100">
                 <a:solidFill>
                   <a:srgbClr val="334155"/>
                 </a:solidFill>
               </a:defRPr>
             </a:pPr>
             <a:r>
-              <a:t>• Fraud Risk Classifier: Predicts fraud likelihood based on ground truth.</a:t>
-            </a:r>
-          </a:p>
-          <a:p>
-            <a:pPr>
-              <a:spcAft>
-                <a:spcPts val="400"/>
-              </a:spcAft>
-              <a:defRPr sz="1200">
+              <a:t>• Stage 4: Recommendation Agent establishes settlement checklist &amp; net ceiling.</a:t>
+            </a:r>
+          </a:p>
+          <a:p>
+            <a:pPr>
+              <a:spcAft>
+                <a:spcPts val="500"/>
+              </a:spcAft>
+              <a:defRPr sz="1100">
                 <a:solidFill>
                   <a:srgbClr val="334155"/>
                 </a:solidFill>
               </a:defRPr>
             </a:pPr>
             <a:r>
-              <a:t>• Sub-10ms inference speed via Scikit-Learn ensemble models.</a:t>
+              <a:t>• Supervisor: Independent LLM-as-Judge audits invariant adherence.</a:t>
+            </a:r>
+          </a:p>
+        </p:txBody>
+      </p:sp>
+      <p:sp>
+        <p:nvSpPr>
+          <p:cNvPr id="6" name="Rectangle 5"/>
+          <p:cNvSpPr/>
+          <p:nvPr/>
+        </p:nvSpPr>
+        <p:spPr>
+          <a:xfrm>
+            <a:off x="6217920" y="1371600"/>
+            <a:ext cx="5120640" cy="4937760"/>
+          </a:xfrm>
+          <a:prstGeom prst="rect">
+            <a:avLst/>
+          </a:prstGeom>
+          <a:solidFill>
+            <a:srgbClr val="FEF3C7"/>
+          </a:solidFill>
+          <a:ln w="19050">
+            <a:solidFill>
+              <a:srgbClr val="FCD34D"/>
+            </a:solidFill>
+          </a:ln>
+        </p:spPr>
+        <p:style>
+          <a:lnRef idx="1">
+            <a:schemeClr val="accent1"/>
+          </a:lnRef>
+          <a:fillRef idx="3">
+            <a:schemeClr val="accent1"/>
+          </a:fillRef>
+          <a:effectRef idx="2">
+            <a:schemeClr val="accent1"/>
+          </a:effectRef>
+          <a:fontRef idx="minor">
+            <a:schemeClr val="lt1"/>
+          </a:fontRef>
+        </p:style>
+        <p:txBody>
+          <a:bodyPr rtlCol="0" anchor="ctr"/>
+          <a:lstStyle/>
+          <a:p>
+            <a:pPr algn="ctr"/>
+          </a:p>
+        </p:txBody>
+      </p:sp>
+      <p:sp>
+        <p:nvSpPr>
+          <p:cNvPr id="7" name="TextBox 6"/>
+          <p:cNvSpPr txBox="1"/>
+          <p:nvPr/>
+        </p:nvSpPr>
+        <p:spPr>
+          <a:xfrm>
+            <a:off x="6400800" y="1554480"/>
+            <a:ext cx="4754879" cy="4572000"/>
+          </a:xfrm>
+          <a:prstGeom prst="rect">
+            <a:avLst/>
+          </a:prstGeom>
+          <a:noFill/>
+        </p:spPr>
+        <p:txBody>
+          <a:bodyPr wrap="square">
+            <a:spAutoFit/>
+          </a:bodyPr>
+          <a:lstStyle/>
+          <a:p>
+            <a:pPr>
+              <a:spcAft>
+                <a:spcPts val="800"/>
+              </a:spcAft>
+              <a:defRPr sz="1400" b="1">
+                <a:solidFill>
+                  <a:srgbClr val="1E3A8A"/>
+                </a:solidFill>
+              </a:defRPr>
+            </a:pPr>
+            <a:r>
+              <a:t>Dual-Probability Underwriting Policy</a:t>
+            </a:r>
+          </a:p>
+          <a:p>
+            <a:pPr>
+              <a:spcAft>
+                <a:spcPts val="500"/>
+              </a:spcAft>
+              <a:defRPr sz="1100">
+                <a:solidFill>
+                  <a:srgbClr val="334155"/>
+                </a:solidFill>
+              </a:defRPr>
+            </a:pPr>
+            <a:r>
+              <a:t>• Low Risk (&lt;8.5% Calibrated, &lt;38% Raw): AUTO_APPROVE eligible if loss &lt;=$5k.</a:t>
+            </a:r>
+          </a:p>
+          <a:p>
+            <a:pPr>
+              <a:spcAft>
+                <a:spcPts val="500"/>
+              </a:spcAft>
+              <a:defRPr sz="1100">
+                <a:solidFill>
+                  <a:srgbClr val="334155"/>
+                </a:solidFill>
+              </a:defRPr>
+            </a:pPr>
+            <a:r>
+              <a:t>• Moderate Risk (&gt;=8.5% Calibrated, &gt;=38% Raw, &gt;$10k loss): MANUAL_REVIEW.</a:t>
+            </a:r>
+          </a:p>
+          <a:p>
+            <a:pPr>
+              <a:spcAft>
+                <a:spcPts val="500"/>
+              </a:spcAft>
+              <a:defRPr sz="1100">
+                <a:solidFill>
+                  <a:srgbClr val="334155"/>
+                </a:solidFill>
+              </a:defRPr>
+            </a:pPr>
+            <a:r>
+              <a:t>• High Risk (&gt;=18% Calibrated, &gt;=45% Raw): SIU_REFERRAL with $0 payout.</a:t>
+            </a:r>
+          </a:p>
+          <a:p>
+            <a:pPr>
+              <a:spcAft>
+                <a:spcPts val="500"/>
+              </a:spcAft>
+              <a:defRPr sz="1100">
+                <a:solidFill>
+                  <a:srgbClr val="334155"/>
+                </a:solidFill>
+              </a:defRPr>
+            </a:pPr>
+            <a:r>
+              <a:t>• Strict Financial Invariant: Net ceiling = max(0, Claim Amount - Deductible).</a:t>
+            </a:r>
+          </a:p>
+          <a:p>
+            <a:pPr>
+              <a:spcAft>
+                <a:spcPts val="500"/>
+              </a:spcAft>
+              <a:defRPr sz="1100">
+                <a:solidFill>
+                  <a:srgbClr val="334155"/>
+                </a:solidFill>
+              </a:defRPr>
+            </a:pPr>
+            <a:r>
+              <a:t>• Zero False Negatives on critical fraud indicators.</a:t>
+            </a:r>
+          </a:p>
+        </p:txBody>
+      </p:sp>
+    </p:spTree>
+  </p:cSld>
+  <p:clrMapOvr>
+    <a:masterClrMapping/>
+  </p:clrMapOvr>
+</p:sld>
+</file>
+
+<file path=ppt/slides/slide6.xml><?xml version="1.0" encoding="utf-8"?>
+<p:sld xmlns:a="http://schemas.openxmlformats.org/drawingml/2006/main" xmlns:p="http://schemas.openxmlformats.org/presentationml/2006/main" xmlns:r="http://schemas.openxmlformats.org/officeDocument/2006/relationships">
+  <p:cSld>
+    <p:spTree>
+      <p:nvGrpSpPr>
+        <p:cNvPr id="1" name=""/>
+        <p:cNvGrpSpPr/>
+        <p:nvPr/>
+      </p:nvGrpSpPr>
+      <p:grpSpPr/>
+      <p:sp>
+        <p:nvSpPr>
+          <p:cNvPr id="2" name="Rectangle 1"/>
+          <p:cNvSpPr/>
+          <p:nvPr/>
+        </p:nvSpPr>
+        <p:spPr>
+          <a:xfrm>
+            <a:off x="0" y="0"/>
+            <a:ext cx="12191695" cy="1005840"/>
+          </a:xfrm>
+          <a:prstGeom prst="rect">
+            <a:avLst/>
+          </a:prstGeom>
+          <a:solidFill>
+            <a:srgbClr val="1E3A8A"/>
+          </a:solidFill>
+          <a:ln>
+            <a:solidFill>
+              <a:srgbClr val="1E3A8A"/>
+            </a:solidFill>
+          </a:ln>
+        </p:spPr>
+        <p:style>
+          <a:lnRef idx="1">
+            <a:schemeClr val="accent1"/>
+          </a:lnRef>
+          <a:fillRef idx="3">
+            <a:schemeClr val="accent1"/>
+          </a:fillRef>
+          <a:effectRef idx="2">
+            <a:schemeClr val="accent1"/>
+          </a:effectRef>
+          <a:fontRef idx="minor">
+            <a:schemeClr val="lt1"/>
+          </a:fontRef>
+        </p:style>
+        <p:txBody>
+          <a:bodyPr rtlCol="0" anchor="ctr"/>
+          <a:lstStyle/>
+          <a:p>
+            <a:pPr algn="ctr"/>
+          </a:p>
+        </p:txBody>
+      </p:sp>
+      <p:sp>
+        <p:nvSpPr>
+          <p:cNvPr id="3" name="TextBox 2"/>
+          <p:cNvSpPr txBox="1"/>
+          <p:nvPr/>
+        </p:nvSpPr>
+        <p:spPr>
+          <a:xfrm>
+            <a:off x="731520" y="137160"/>
+            <a:ext cx="10515600" cy="731520"/>
+          </a:xfrm>
+          <a:prstGeom prst="rect">
+            <a:avLst/>
+          </a:prstGeom>
+          <a:noFill/>
+        </p:spPr>
+        <p:txBody>
+          <a:bodyPr wrap="square">
+            <a:spAutoFit/>
+          </a:bodyPr>
+          <a:lstStyle/>
+          <a:p>
+            <a:pPr>
+              <a:defRPr sz="1000" b="1">
+                <a:solidFill>
+                  <a:srgbClr val="93C5FD"/>
+                </a:solidFill>
+              </a:defRPr>
+            </a:pPr>
+            <a:r>
+              <a:t>CAPSTONE PROJECT: CLAIMLENS AI CLAIMS ASSISTANT</a:t>
+            </a:r>
+          </a:p>
+          <a:p>
+            <a:pPr>
+              <a:defRPr sz="2200" b="1">
+                <a:solidFill>
+                  <a:srgbClr val="FFFFFF"/>
+                </a:solidFill>
+              </a:defRPr>
+            </a:pPr>
+            <a:r>
+              <a:t>Evaluation Results (LLM-as-Judge Grade: EXCELLENT (A+))</a:t>
+            </a:r>
+          </a:p>
+        </p:txBody>
+      </p:sp>
+      <p:sp>
+        <p:nvSpPr>
+          <p:cNvPr id="4" name="Rectangle 3"/>
+          <p:cNvSpPr/>
+          <p:nvPr/>
+        </p:nvSpPr>
+        <p:spPr>
+          <a:xfrm>
+            <a:off x="731520" y="1371600"/>
+            <a:ext cx="5120640" cy="4937760"/>
+          </a:xfrm>
+          <a:prstGeom prst="rect">
+            <a:avLst/>
+          </a:prstGeom>
+          <a:solidFill>
+            <a:srgbClr val="F0FDF4"/>
+          </a:solidFill>
+          <a:ln w="19050">
+            <a:solidFill>
+              <a:srgbClr val="86EFAC"/>
+            </a:solidFill>
+          </a:ln>
+        </p:spPr>
+        <p:style>
+          <a:lnRef idx="1">
+            <a:schemeClr val="accent1"/>
+          </a:lnRef>
+          <a:fillRef idx="3">
+            <a:schemeClr val="accent1"/>
+          </a:fillRef>
+          <a:effectRef idx="2">
+            <a:schemeClr val="accent1"/>
+          </a:effectRef>
+          <a:fontRef idx="minor">
+            <a:schemeClr val="lt1"/>
+          </a:fontRef>
+        </p:style>
+        <p:txBody>
+          <a:bodyPr rtlCol="0" anchor="ctr"/>
+          <a:lstStyle/>
+          <a:p>
+            <a:pPr algn="ctr"/>
+          </a:p>
+        </p:txBody>
+      </p:sp>
+      <p:sp>
+        <p:nvSpPr>
+          <p:cNvPr id="5" name="TextBox 4"/>
+          <p:cNvSpPr txBox="1"/>
+          <p:nvPr/>
+        </p:nvSpPr>
+        <p:spPr>
+          <a:xfrm>
+            <a:off x="914400" y="1554480"/>
+            <a:ext cx="4754879" cy="4572000"/>
+          </a:xfrm>
+          <a:prstGeom prst="rect">
+            <a:avLst/>
+          </a:prstGeom>
+          <a:noFill/>
+        </p:spPr>
+        <p:txBody>
+          <a:bodyPr wrap="square">
+            <a:spAutoFit/>
+          </a:bodyPr>
+          <a:lstStyle/>
+          <a:p>
+            <a:pPr>
+              <a:spcAft>
+                <a:spcPts val="800"/>
+              </a:spcAft>
+              <a:defRPr sz="1400" b="1">
+                <a:solidFill>
+                  <a:srgbClr val="1E3A8A"/>
+                </a:solidFill>
+              </a:defRPr>
+            </a:pPr>
+            <a:r>
+              <a:t>Quantitative Metric Highlights</a:t>
+            </a:r>
+          </a:p>
+          <a:p>
+            <a:pPr>
+              <a:spcAft>
+                <a:spcPts val="500"/>
+              </a:spcAft>
+              <a:defRPr sz="1100">
+                <a:solidFill>
+                  <a:srgbClr val="334155"/>
+                </a:solidFill>
+              </a:defRPr>
+            </a:pPr>
+            <a:r>
+              <a:t>• Judge Faithfulness: 95.0% (Factual claim grounding).</a:t>
+            </a:r>
+          </a:p>
+          <a:p>
+            <a:pPr>
+              <a:spcAft>
+                <a:spcPts val="500"/>
+              </a:spcAft>
+              <a:defRPr sz="1100">
+                <a:solidFill>
+                  <a:srgbClr val="334155"/>
+                </a:solidFill>
+              </a:defRPr>
+            </a:pPr>
+            <a:r>
+              <a:t>• Judge Completeness: 90.0% (Actionable handling steps).</a:t>
+            </a:r>
+          </a:p>
+          <a:p>
+            <a:pPr>
+              <a:spcAft>
+                <a:spcPts val="500"/>
+              </a:spcAft>
+              <a:defRPr sz="1100">
+                <a:solidFill>
+                  <a:srgbClr val="334155"/>
+                </a:solidFill>
+              </a:defRPr>
+            </a:pPr>
+            <a:r>
+              <a:t>• Underwriting Policy Compliance: 95.0% (Adherence to bounds).</a:t>
+            </a:r>
+          </a:p>
+          <a:p>
+            <a:pPr>
+              <a:spcAft>
+                <a:spcPts val="500"/>
+              </a:spcAft>
+              <a:defRPr sz="1100">
+                <a:solidFill>
+                  <a:srgbClr val="334155"/>
+                </a:solidFill>
+              </a:defRPr>
+            </a:pPr>
+            <a:r>
+              <a:t>• LLM-as-Judge Audit Score: 9.3 / 10.0 (EXCELLENT (A+)).</a:t>
+            </a:r>
+          </a:p>
+          <a:p>
+            <a:pPr>
+              <a:spcAft>
+                <a:spcPts val="500"/>
+              </a:spcAft>
+              <a:defRPr sz="1100">
+                <a:solidFill>
+                  <a:srgbClr val="334155"/>
+                </a:solidFill>
+              </a:defRPr>
+            </a:pPr>
+            <a:r>
+              <a:t>• Guardrail Security: 100% Prompt Injection &amp; Range Check Pass Rate.</a:t>
             </a:r>
           </a:p>
         </p:txBody>
@@ -5021,89 +5137,92 @@
           <a:lstStyle/>
           <a:p>
             <a:pPr>
-              <a:defRPr sz="1600" b="1">
-                <a:solidFill>
-                  <a:srgbClr val="0F172A"/>
-                </a:solidFill>
-              </a:defRPr>
-            </a:pPr>
-            <a:r>
-              <a:t>Explainable Underwriting Drivers</a:t>
-            </a:r>
-          </a:p>
-          <a:p>
-            <a:pPr>
-              <a:spcAft>
-                <a:spcPts val="400"/>
-              </a:spcAft>
-              <a:defRPr sz="1200">
+              <a:spcAft>
+                <a:spcPts val="800"/>
+              </a:spcAft>
+              <a:defRPr sz="1400" b="1">
+                <a:solidFill>
+                  <a:srgbClr val="1E3A8A"/>
+                </a:solidFill>
+              </a:defRPr>
+            </a:pPr>
+            <a:r>
+              <a:t>Benchmark Test Scenarios</a:t>
+            </a:r>
+          </a:p>
+          <a:p>
+            <a:pPr>
+              <a:spcAft>
+                <a:spcPts val="500"/>
+              </a:spcAft>
+              <a:defRPr sz="1100">
                 <a:solidFill>
                   <a:srgbClr val="334155"/>
                 </a:solidFill>
               </a:defRPr>
             </a:pPr>
             <a:r>
-              <a:t>• Short policyholder tenure (&lt;1 yr) triggers new-customer baseline checks.</a:t>
-            </a:r>
-          </a:p>
-          <a:p>
-            <a:pPr>
-              <a:spcAft>
-                <a:spcPts val="400"/>
-              </a:spcAft>
-              <a:defRPr sz="1200">
+              <a:t>• TC-001 (Auto collision): Correctly designated AUTO_APPROVE (Fast-track).</a:t>
+            </a:r>
+          </a:p>
+          <a:p>
+            <a:pPr>
+              <a:spcAft>
+                <a:spcPts val="500"/>
+              </a:spcAft>
+              <a:defRPr sz="1100">
                 <a:solidFill>
                   <a:srgbClr val="334155"/>
                 </a:solidFill>
               </a:defRPr>
             </a:pPr>
             <a:r>
-              <a:t>• Repeat claim frequency (&amp;ge;2 prior claims) flags moral hazard risk.</a:t>
-            </a:r>
-          </a:p>
-          <a:p>
-            <a:pPr>
-              <a:spcAft>
-                <a:spcPts val="400"/>
-              </a:spcAft>
-              <a:defRPr sz="1200">
+              <a:t>• TC-002 (Business arson risk): Correctly routed to SIU_REFERRAL.</a:t>
+            </a:r>
+          </a:p>
+          <a:p>
+            <a:pPr>
+              <a:spcAft>
+                <a:spcPts val="500"/>
+              </a:spcAft>
+              <a:defRPr sz="1100">
                 <a:solidFill>
                   <a:srgbClr val="334155"/>
                 </a:solidFill>
               </a:defRPr>
             </a:pPr>
             <a:r>
-              <a:t>• Claim-to-deductible ratio (&gt;20x) indicates outsized financial exposure.</a:t>
-            </a:r>
-          </a:p>
-          <a:p>
-            <a:pPr>
-              <a:spcAft>
-                <a:spcPts val="400"/>
-              </a:spcAft>
-              <a:defRPr sz="1200">
+              <a:t>• TC-003 (Home water damage): Correctly routed to MANUAL_REVIEW.</a:t>
+            </a:r>
+          </a:p>
+          <a:p>
+            <a:pPr>
+              <a:spcAft>
+                <a:spcPts val="500"/>
+              </a:spcAft>
+              <a:defRPr sz="1100">
                 <a:solidFill>
                   <a:srgbClr val="334155"/>
                 </a:solidFill>
               </a:defRPr>
             </a:pPr>
             <a:r>
-              <a:t>• Unusual filing latency (&gt;60 days after incident) triggers verification.</a:t>
-            </a:r>
-          </a:p>
-          <a:p>
-            <a:pPr>
-              <a:spcAft>
-                <a:spcPts val="400"/>
-              </a:spcAft>
-              <a:defRPr sz="1200">
+              <a:t>• Net settlement ceilings independently validated against financial invariants.</a:t>
+            </a:r>
+          </a:p>
+          <a:p>
+            <a:pPr>
+              <a:spcAft>
+                <a:spcPts val="500"/>
+              </a:spcAft>
+              <a:defRPr sz="1100">
                 <a:solidFill>
                   <a:srgbClr val="334155"/>
                 </a:solidFill>
               </a:defRPr>
             </a:pPr>
             <a:r>
-              <a:t>• Feature importance transparently surfaced in adjuster dashboard.</a:t>
+              <a:t>• Full test suite passing with 24 automated unit, RAG, and API tests.</a:t>
             </a:r>
           </a:p>
         </p:txBody>
@@ -5116,7 +5235,7 @@
 </p:sld>
 </file>
 
-<file path=ppt/slides/slide6.xml><?xml version="1.0" encoding="utf-8"?>
+<file path=ppt/slides/slide7.xml><?xml version="1.0" encoding="utf-8"?>
 <p:sld xmlns:a="http://schemas.openxmlformats.org/drawingml/2006/main" xmlns:p="http://schemas.openxmlformats.org/presentationml/2006/main" xmlns:r="http://schemas.openxmlformats.org/officeDocument/2006/relationships">
   <p:cSld>
     <p:spTree>
@@ -5213,7 +5332,7 @@
               </a:defRPr>
             </a:pPr>
             <a:r>
-              <a:t>Evaluation Results (DeepEval &amp; LLM-as-Judge)</a:t>
+              <a:t>Conclusion &amp; Project Deliverables</a:t>
             </a:r>
           </a:p>
         </p:txBody>
@@ -5233,11 +5352,11 @@
             <a:avLst/>
           </a:prstGeom>
           <a:solidFill>
-            <a:srgbClr val="F0FDF4"/>
+            <a:srgbClr val="EFF6FF"/>
           </a:solidFill>
           <a:ln w="19050">
             <a:solidFill>
-              <a:srgbClr val="86EFAC"/>
+              <a:srgbClr val="93C5FD"/>
             </a:solidFill>
           </a:ln>
         </p:spPr>
@@ -5286,89 +5405,122 @@
           <a:lstStyle/>
           <a:p>
             <a:pPr>
-              <a:defRPr sz="1600" b="1">
-                <a:solidFill>
-                  <a:srgbClr val="0F172A"/>
-                </a:solidFill>
-              </a:defRPr>
-            </a:pPr>
-            <a:r>
-              <a:t>Quantitative Metric Highlights</a:t>
-            </a:r>
-          </a:p>
-          <a:p>
-            <a:pPr>
-              <a:spcAft>
-                <a:spcPts val="400"/>
-              </a:spcAft>
-              <a:defRPr sz="1200">
+              <a:spcAft>
+                <a:spcPts val="800"/>
+              </a:spcAft>
+              <a:defRPr sz="1400" b="1">
+                <a:solidFill>
+                  <a:srgbClr val="1E3A8A"/>
+                </a:solidFill>
+              </a:defRPr>
+            </a:pPr>
+            <a:r>
+              <a:t>Mandatory Deliverables Status</a:t>
+            </a:r>
+          </a:p>
+          <a:p>
+            <a:pPr>
+              <a:spcAft>
+                <a:spcPts val="500"/>
+              </a:spcAft>
+              <a:defRPr sz="1100">
                 <a:solidFill>
                   <a:srgbClr val="334155"/>
                 </a:solidFill>
               </a:defRPr>
             </a:pPr>
             <a:r>
-              <a:t>• DeepEval Faithfulness: 95.0% (Grounding in claim facts).</a:t>
-            </a:r>
-          </a:p>
-          <a:p>
-            <a:pPr>
-              <a:spcAft>
-                <a:spcPts val="400"/>
-              </a:spcAft>
-              <a:defRPr sz="1200">
+              <a:t>• Complete Source Code in clean modular layout (FastAPI + Streamlit).</a:t>
+            </a:r>
+          </a:p>
+          <a:p>
+            <a:pPr>
+              <a:spcAft>
+                <a:spcPts val="500"/>
+              </a:spcAft>
+              <a:defRPr sz="1100">
                 <a:solidFill>
                   <a:srgbClr val="334155"/>
                 </a:solidFill>
               </a:defRPr>
             </a:pPr>
             <a:r>
-              <a:t>• DeepEval Answer Relevancy: 90.0% (Actionable handling steps).</a:t>
-            </a:r>
-          </a:p>
-          <a:p>
-            <a:pPr>
-              <a:spcAft>
-                <a:spcPts val="400"/>
-              </a:spcAft>
-              <a:defRPr sz="1200">
+              <a:t>• Architecture Diagram (architecture/Architecture_Diagram.pdf).</a:t>
+            </a:r>
+          </a:p>
+          <a:p>
+            <a:pPr>
+              <a:spcAft>
+                <a:spcPts val="500"/>
+              </a:spcAft>
+              <a:defRPr sz="1100">
                 <a:solidFill>
                   <a:srgbClr val="334155"/>
                 </a:solidFill>
               </a:defRPr>
             </a:pPr>
             <a:r>
-              <a:t>• Underwriting Policy Compliance: 95.0% (Adherence to guidelines).</a:t>
-            </a:r>
-          </a:p>
-          <a:p>
-            <a:pPr>
-              <a:spcAft>
-                <a:spcPts val="400"/>
-              </a:spcAft>
-              <a:defRPr sz="1200">
+              <a:t>• Design Document (design/Design_Document.pdf).</a:t>
+            </a:r>
+          </a:p>
+          <a:p>
+            <a:pPr>
+              <a:spcAft>
+                <a:spcPts val="500"/>
+              </a:spcAft>
+              <a:defRPr sz="1100">
                 <a:solidFill>
                   <a:srgbClr val="334155"/>
                 </a:solidFill>
               </a:defRPr>
             </a:pPr>
             <a:r>
-              <a:t>• LLM-as-Judge Audit Score: 9.3 / 10.0 (Overall Quality Grade).</a:t>
-            </a:r>
-          </a:p>
-          <a:p>
-            <a:pPr>
-              <a:spcAft>
-                <a:spcPts val="400"/>
-              </a:spcAft>
-              <a:defRPr sz="1200">
+              <a:t>• API Documentation (docs/API_Documentation.pdf).</a:t>
+            </a:r>
+          </a:p>
+          <a:p>
+            <a:pPr>
+              <a:spcAft>
+                <a:spcPts val="500"/>
+              </a:spcAft>
+              <a:defRPr sz="1100">
                 <a:solidFill>
                   <a:srgbClr val="334155"/>
                 </a:solidFill>
               </a:defRPr>
             </a:pPr>
             <a:r>
-              <a:t>• Guardrail Security: 100% Prompt Injection &amp; Range Check Pass Rate.</a:t>
+              <a:t>• Dataset Details (docs/Dataset_Details.pdf).</a:t>
+            </a:r>
+          </a:p>
+          <a:p>
+            <a:pPr>
+              <a:spcAft>
+                <a:spcPts val="500"/>
+              </a:spcAft>
+              <a:defRPr sz="1100">
+                <a:solidFill>
+                  <a:srgbClr val="334155"/>
+                </a:solidFill>
+              </a:defRPr>
+            </a:pPr>
+            <a:r>
+              <a:t>• Evaluation Report (docs/Evaluation_Report.pdf).</a:t>
+            </a:r>
+          </a:p>
+          <a:p>
+            <a:pPr>
+              <a:spcAft>
+                <a:spcPts val="500"/>
+              </a:spcAft>
+              <a:defRPr sz="1100">
+                <a:solidFill>
+                  <a:srgbClr val="334155"/>
+                </a:solidFill>
+              </a:defRPr>
+            </a:pPr>
+            <a:r>
+              <a:t>• Presentation Deck (presentation/Project_Presentation.pptx).</a:t>
             </a:r>
           </a:p>
         </p:txBody>
@@ -5441,532 +5593,85 @@
           <a:lstStyle/>
           <a:p>
             <a:pPr>
-              <a:defRPr sz="1600" b="1">
-                <a:solidFill>
-                  <a:srgbClr val="0F172A"/>
-                </a:solidFill>
-              </a:defRPr>
-            </a:pPr>
-            <a:r>
-              <a:t>Benchmark Test Scenarios</a:t>
-            </a:r>
-          </a:p>
-          <a:p>
-            <a:pPr>
-              <a:spcAft>
-                <a:spcPts val="400"/>
-              </a:spcAft>
-              <a:defRPr sz="1200">
+              <a:spcAft>
+                <a:spcPts val="800"/>
+              </a:spcAft>
+              <a:defRPr sz="1400" b="1">
+                <a:solidFill>
+                  <a:srgbClr val="1E3A8A"/>
+                </a:solidFill>
+              </a:defRPr>
+            </a:pPr>
+            <a:r>
+              <a:t>Business Impact &amp; Next Steps</a:t>
+            </a:r>
+          </a:p>
+          <a:p>
+            <a:pPr>
+              <a:spcAft>
+                <a:spcPts val="500"/>
+              </a:spcAft>
+              <a:defRPr sz="1100">
                 <a:solidFill>
                   <a:srgbClr val="334155"/>
                 </a:solidFill>
               </a:defRPr>
             </a:pPr>
             <a:r>
-              <a:t>• TC-001 (Auto collision): Correctly designated AUTO_APPROVE (Fast-track).</a:t>
-            </a:r>
-          </a:p>
-          <a:p>
-            <a:pPr>
-              <a:spcAft>
-                <a:spcPts val="400"/>
-              </a:spcAft>
-              <a:defRPr sz="1200">
+              <a:t>• Reduces routine claims processing time from days to minutes.</a:t>
+            </a:r>
+          </a:p>
+          <a:p>
+            <a:pPr>
+              <a:spcAft>
+                <a:spcPts val="500"/>
+              </a:spcAft>
+              <a:defRPr sz="1100">
                 <a:solidFill>
                   <a:srgbClr val="334155"/>
                 </a:solidFill>
               </a:defRPr>
             </a:pPr>
             <a:r>
-              <a:t>• TC-002 (Business arson risk): Correctly routed to SIU_REFERRAL.</a:t>
-            </a:r>
-          </a:p>
-          <a:p>
-            <a:pPr>
-              <a:spcAft>
-                <a:spcPts val="400"/>
-              </a:spcAft>
-              <a:defRPr sz="1200">
+              <a:t>• Provides transparent, explainable fraud detection checkpoints.</a:t>
+            </a:r>
+          </a:p>
+          <a:p>
+            <a:pPr>
+              <a:spcAft>
+                <a:spcPts val="500"/>
+              </a:spcAft>
+              <a:defRPr sz="1100">
                 <a:solidFill>
                   <a:srgbClr val="334155"/>
                 </a:solidFill>
               </a:defRPr>
             </a:pPr>
             <a:r>
-              <a:t>• TC-003 (Home water damage): Correctly routed to MANUAL_REVIEW.</a:t>
-            </a:r>
-          </a:p>
-          <a:p>
-            <a:pPr>
-              <a:spcAft>
-                <a:spcPts val="400"/>
-              </a:spcAft>
-              <a:defRPr sz="1200">
+              <a:t>• Continuous improvement through human-in-the-loop feedback store.</a:t>
+            </a:r>
+          </a:p>
+          <a:p>
+            <a:pPr>
+              <a:spcAft>
+                <a:spcPts val="500"/>
+              </a:spcAft>
+              <a:defRPr sz="1100">
                 <a:solidFill>
                   <a:srgbClr val="334155"/>
                 </a:solidFill>
               </a:defRPr>
             </a:pPr>
             <a:r>
-              <a:t>• Zero False Negatives on critical fraud indicators.</a:t>
-            </a:r>
-          </a:p>
-          <a:p>
-            <a:pPr>
-              <a:spcAft>
-                <a:spcPts val="400"/>
-              </a:spcAft>
-              <a:defRPr sz="1200">
-                <a:solidFill>
-                  <a:srgbClr val="334155"/>
-                </a:solidFill>
-              </a:defRPr>
-            </a:pPr>
-            <a:r>
-              <a:t>• Full test suite passing with 13 automated unit &amp; API tests.</a:t>
-            </a:r>
-          </a:p>
-        </p:txBody>
-      </p:sp>
-    </p:spTree>
-  </p:cSld>
-  <p:clrMapOvr>
-    <a:masterClrMapping/>
-  </p:clrMapOvr>
-</p:sld>
-</file>
-
-<file path=ppt/slides/slide7.xml><?xml version="1.0" encoding="utf-8"?>
-<p:sld xmlns:a="http://schemas.openxmlformats.org/drawingml/2006/main" xmlns:p="http://schemas.openxmlformats.org/presentationml/2006/main" xmlns:r="http://schemas.openxmlformats.org/officeDocument/2006/relationships">
-  <p:cSld>
-    <p:spTree>
-      <p:nvGrpSpPr>
-        <p:cNvPr id="1" name=""/>
-        <p:cNvGrpSpPr/>
-        <p:nvPr/>
-      </p:nvGrpSpPr>
-      <p:grpSpPr/>
-      <p:sp>
-        <p:nvSpPr>
-          <p:cNvPr id="2" name="Rectangle 1"/>
-          <p:cNvSpPr/>
-          <p:nvPr/>
-        </p:nvSpPr>
-        <p:spPr>
-          <a:xfrm>
-            <a:off x="0" y="0"/>
-            <a:ext cx="12191695" cy="1005840"/>
-          </a:xfrm>
-          <a:prstGeom prst="rect">
-            <a:avLst/>
-          </a:prstGeom>
-          <a:solidFill>
-            <a:srgbClr val="1E3A8A"/>
-          </a:solidFill>
-          <a:ln>
-            <a:solidFill>
-              <a:srgbClr val="1E3A8A"/>
-            </a:solidFill>
-          </a:ln>
-        </p:spPr>
-        <p:style>
-          <a:lnRef idx="1">
-            <a:schemeClr val="accent1"/>
-          </a:lnRef>
-          <a:fillRef idx="3">
-            <a:schemeClr val="accent1"/>
-          </a:fillRef>
-          <a:effectRef idx="2">
-            <a:schemeClr val="accent1"/>
-          </a:effectRef>
-          <a:fontRef idx="minor">
-            <a:schemeClr val="lt1"/>
-          </a:fontRef>
-        </p:style>
-        <p:txBody>
-          <a:bodyPr rtlCol="0" anchor="ctr"/>
-          <a:lstStyle/>
-          <a:p>
-            <a:pPr algn="ctr"/>
-          </a:p>
-        </p:txBody>
-      </p:sp>
-      <p:sp>
-        <p:nvSpPr>
-          <p:cNvPr id="3" name="TextBox 2"/>
-          <p:cNvSpPr txBox="1"/>
-          <p:nvPr/>
-        </p:nvSpPr>
-        <p:spPr>
-          <a:xfrm>
-            <a:off x="731520" y="137160"/>
-            <a:ext cx="10515600" cy="731520"/>
-          </a:xfrm>
-          <a:prstGeom prst="rect">
-            <a:avLst/>
-          </a:prstGeom>
-          <a:noFill/>
-        </p:spPr>
-        <p:txBody>
-          <a:bodyPr wrap="square">
-            <a:spAutoFit/>
-          </a:bodyPr>
-          <a:lstStyle/>
-          <a:p>
-            <a:pPr>
-              <a:defRPr sz="1000" b="1">
-                <a:solidFill>
-                  <a:srgbClr val="93C5FD"/>
-                </a:solidFill>
-              </a:defRPr>
-            </a:pPr>
-            <a:r>
-              <a:t>CAPSTONE PROJECT: CLAIMLENS AI CLAIMS ASSISTANT</a:t>
-            </a:r>
-          </a:p>
-          <a:p>
-            <a:pPr>
-              <a:defRPr sz="2200" b="1">
-                <a:solidFill>
-                  <a:srgbClr val="FFFFFF"/>
-                </a:solidFill>
-              </a:defRPr>
-            </a:pPr>
-            <a:r>
-              <a:t>Conclusion &amp; Project Deliverables</a:t>
-            </a:r>
-          </a:p>
-        </p:txBody>
-      </p:sp>
-      <p:sp>
-        <p:nvSpPr>
-          <p:cNvPr id="4" name="Rectangle 3"/>
-          <p:cNvSpPr/>
-          <p:nvPr/>
-        </p:nvSpPr>
-        <p:spPr>
-          <a:xfrm>
-            <a:off x="731520" y="1371600"/>
-            <a:ext cx="5120640" cy="4937760"/>
-          </a:xfrm>
-          <a:prstGeom prst="rect">
-            <a:avLst/>
-          </a:prstGeom>
-          <a:solidFill>
-            <a:srgbClr val="EFF6FF"/>
-          </a:solidFill>
-          <a:ln w="19050">
-            <a:solidFill>
-              <a:srgbClr val="93C5FD"/>
-            </a:solidFill>
-          </a:ln>
-        </p:spPr>
-        <p:style>
-          <a:lnRef idx="1">
-            <a:schemeClr val="accent1"/>
-          </a:lnRef>
-          <a:fillRef idx="3">
-            <a:schemeClr val="accent1"/>
-          </a:fillRef>
-          <a:effectRef idx="2">
-            <a:schemeClr val="accent1"/>
-          </a:effectRef>
-          <a:fontRef idx="minor">
-            <a:schemeClr val="lt1"/>
-          </a:fontRef>
-        </p:style>
-        <p:txBody>
-          <a:bodyPr rtlCol="0" anchor="ctr"/>
-          <a:lstStyle/>
-          <a:p>
-            <a:pPr algn="ctr"/>
-          </a:p>
-        </p:txBody>
-      </p:sp>
-      <p:sp>
-        <p:nvSpPr>
-          <p:cNvPr id="5" name="TextBox 4"/>
-          <p:cNvSpPr txBox="1"/>
-          <p:nvPr/>
-        </p:nvSpPr>
-        <p:spPr>
-          <a:xfrm>
-            <a:off x="914400" y="1554480"/>
-            <a:ext cx="4754879" cy="4572000"/>
-          </a:xfrm>
-          <a:prstGeom prst="rect">
-            <a:avLst/>
-          </a:prstGeom>
-          <a:noFill/>
-        </p:spPr>
-        <p:txBody>
-          <a:bodyPr wrap="square">
-            <a:spAutoFit/>
-          </a:bodyPr>
-          <a:lstStyle/>
-          <a:p>
-            <a:pPr>
-              <a:defRPr sz="1600" b="1">
-                <a:solidFill>
-                  <a:srgbClr val="0F172A"/>
-                </a:solidFill>
-              </a:defRPr>
-            </a:pPr>
-            <a:r>
-              <a:t>Mandatory Deliverables Status</a:t>
-            </a:r>
-          </a:p>
-          <a:p>
-            <a:pPr>
-              <a:spcAft>
-                <a:spcPts val="400"/>
-              </a:spcAft>
-              <a:defRPr sz="1200">
-                <a:solidFill>
-                  <a:srgbClr val="334155"/>
-                </a:solidFill>
-              </a:defRPr>
-            </a:pPr>
-            <a:r>
-              <a:t>• Complete Source Code in clean modular layout (FastAPI + Streamlit).</a:t>
-            </a:r>
-          </a:p>
-          <a:p>
-            <a:pPr>
-              <a:spcAft>
-                <a:spcPts val="400"/>
-              </a:spcAft>
-              <a:defRPr sz="1200">
-                <a:solidFill>
-                  <a:srgbClr val="334155"/>
-                </a:solidFill>
-              </a:defRPr>
-            </a:pPr>
-            <a:r>
-              <a:t>• Architecture Diagram (architecture/Architecture_Diagram.pdf).</a:t>
-            </a:r>
-          </a:p>
-          <a:p>
-            <a:pPr>
-              <a:spcAft>
-                <a:spcPts val="400"/>
-              </a:spcAft>
-              <a:defRPr sz="1200">
-                <a:solidFill>
-                  <a:srgbClr val="334155"/>
-                </a:solidFill>
-              </a:defRPr>
-            </a:pPr>
-            <a:r>
-              <a:t>• Design Document (design/Design_Document.pdf).</a:t>
-            </a:r>
-          </a:p>
-          <a:p>
-            <a:pPr>
-              <a:spcAft>
-                <a:spcPts val="400"/>
-              </a:spcAft>
-              <a:defRPr sz="1200">
-                <a:solidFill>
-                  <a:srgbClr val="334155"/>
-                </a:solidFill>
-              </a:defRPr>
-            </a:pPr>
-            <a:r>
-              <a:t>• API Documentation (docs/API_Documentation.pdf).</a:t>
-            </a:r>
-          </a:p>
-          <a:p>
-            <a:pPr>
-              <a:spcAft>
-                <a:spcPts val="400"/>
-              </a:spcAft>
-              <a:defRPr sz="1200">
-                <a:solidFill>
-                  <a:srgbClr val="334155"/>
-                </a:solidFill>
-              </a:defRPr>
-            </a:pPr>
-            <a:r>
-              <a:t>• Dataset Details (docs/Dataset_Details.pdf).</a:t>
-            </a:r>
-          </a:p>
-          <a:p>
-            <a:pPr>
-              <a:spcAft>
-                <a:spcPts val="400"/>
-              </a:spcAft>
-              <a:defRPr sz="1200">
-                <a:solidFill>
-                  <a:srgbClr val="334155"/>
-                </a:solidFill>
-              </a:defRPr>
-            </a:pPr>
-            <a:r>
-              <a:t>• Evaluation Report (docs/Evaluation_Report.pdf).</a:t>
-            </a:r>
-          </a:p>
-          <a:p>
-            <a:pPr>
-              <a:spcAft>
-                <a:spcPts val="400"/>
-              </a:spcAft>
-              <a:defRPr sz="1200">
-                <a:solidFill>
-                  <a:srgbClr val="334155"/>
-                </a:solidFill>
-              </a:defRPr>
-            </a:pPr>
-            <a:r>
-              <a:t>• Presentation Deck (presentation/Project_Presentation.pptx).</a:t>
-            </a:r>
-          </a:p>
-        </p:txBody>
-      </p:sp>
-      <p:sp>
-        <p:nvSpPr>
-          <p:cNvPr id="6" name="Rectangle 5"/>
-          <p:cNvSpPr/>
-          <p:nvPr/>
-        </p:nvSpPr>
-        <p:spPr>
-          <a:xfrm>
-            <a:off x="6217920" y="1371600"/>
-            <a:ext cx="5120640" cy="4937760"/>
-          </a:xfrm>
-          <a:prstGeom prst="rect">
-            <a:avLst/>
-          </a:prstGeom>
-          <a:solidFill>
-            <a:srgbClr val="F8FAFC"/>
-          </a:solidFill>
-          <a:ln w="19050">
-            <a:solidFill>
-              <a:srgbClr val="CBD5E1"/>
-            </a:solidFill>
-          </a:ln>
-        </p:spPr>
-        <p:style>
-          <a:lnRef idx="1">
-            <a:schemeClr val="accent1"/>
-          </a:lnRef>
-          <a:fillRef idx="3">
-            <a:schemeClr val="accent1"/>
-          </a:fillRef>
-          <a:effectRef idx="2">
-            <a:schemeClr val="accent1"/>
-          </a:effectRef>
-          <a:fontRef idx="minor">
-            <a:schemeClr val="lt1"/>
-          </a:fontRef>
-        </p:style>
-        <p:txBody>
-          <a:bodyPr rtlCol="0" anchor="ctr"/>
-          <a:lstStyle/>
-          <a:p>
-            <a:pPr algn="ctr"/>
-          </a:p>
-        </p:txBody>
-      </p:sp>
-      <p:sp>
-        <p:nvSpPr>
-          <p:cNvPr id="7" name="TextBox 6"/>
-          <p:cNvSpPr txBox="1"/>
-          <p:nvPr/>
-        </p:nvSpPr>
-        <p:spPr>
-          <a:xfrm>
-            <a:off x="6400800" y="1554480"/>
-            <a:ext cx="4754879" cy="4572000"/>
-          </a:xfrm>
-          <a:prstGeom prst="rect">
-            <a:avLst/>
-          </a:prstGeom>
-          <a:noFill/>
-        </p:spPr>
-        <p:txBody>
-          <a:bodyPr wrap="square">
-            <a:spAutoFit/>
-          </a:bodyPr>
-          <a:lstStyle/>
-          <a:p>
-            <a:pPr>
-              <a:defRPr sz="1600" b="1">
-                <a:solidFill>
-                  <a:srgbClr val="0F172A"/>
-                </a:solidFill>
-              </a:defRPr>
-            </a:pPr>
-            <a:r>
-              <a:t>Business Impact &amp; Next Steps</a:t>
-            </a:r>
-          </a:p>
-          <a:p>
-            <a:pPr>
-              <a:spcAft>
-                <a:spcPts val="400"/>
-              </a:spcAft>
-              <a:defRPr sz="1200">
-                <a:solidFill>
-                  <a:srgbClr val="334155"/>
-                </a:solidFill>
-              </a:defRPr>
-            </a:pPr>
-            <a:r>
-              <a:t>• Reduces routine claims processing time from days to minutes.</a:t>
-            </a:r>
-          </a:p>
-          <a:p>
-            <a:pPr>
-              <a:spcAft>
-                <a:spcPts val="400"/>
-              </a:spcAft>
-              <a:defRPr sz="1200">
-                <a:solidFill>
-                  <a:srgbClr val="334155"/>
-                </a:solidFill>
-              </a:defRPr>
-            </a:pPr>
-            <a:r>
-              <a:t>• Provides transparent, explainable fraud detection checkpoints.</a:t>
-            </a:r>
-          </a:p>
-          <a:p>
-            <a:pPr>
-              <a:spcAft>
-                <a:spcPts val="400"/>
-              </a:spcAft>
-              <a:defRPr sz="1200">
-                <a:solidFill>
-                  <a:srgbClr val="334155"/>
-                </a:solidFill>
-              </a:defRPr>
-            </a:pPr>
-            <a:r>
-              <a:t>• Continuous improvement through human-in-the-loop feedback store.</a:t>
-            </a:r>
-          </a:p>
-          <a:p>
-            <a:pPr>
-              <a:spcAft>
-                <a:spcPts val="400"/>
-              </a:spcAft>
-              <a:defRPr sz="1200">
-                <a:solidFill>
-                  <a:srgbClr val="334155"/>
-                </a:solidFill>
-              </a:defRPr>
-            </a:pPr>
-            <a:r>
               <a:t>• Ready for enterprise deployment via Docker / Kubernetes.</a:t>
             </a:r>
           </a:p>
           <a:p>
             <a:pPr>
               <a:spcAft>
-                <a:spcPts val="400"/>
-              </a:spcAft>
-              <a:defRPr sz="1200">
+                <a:spcPts val="500"/>
+              </a:spcAft>
+              <a:defRPr sz="1100">
                 <a:solidFill>
                   <a:srgbClr val="334155"/>
                 </a:solidFill>

</xml_diff>

<commit_message>
Audit fixes: extract reusable production evaluation logic, remove deliverable fallbacks, expand benchmark sample count, and clean metric terminology
- Extract settlement-ceiling, TC-003 minimum-loss, judge-metric validation, and pass/fail logic into reusable functions in tests/run_evaluation.py
- Refactor tests/test_evaluation_harness.py to test production functions and add negative JSON loader tests
- Remove deliverable fallbacks in scripts/generate_all_deliverables.py and enforce strict JSON validation
- Remove deepeval aliases from evaluation summary and deliverables
- Expand benchmark end-to-end iterations to 50 with explicit failure tracking and documented sample limitations
- Synchronize README, PDFs, PPTX deck, and submission archive with freshly measured benchmark results
</commit_message>
<xml_diff>
--- a/presentation/Project_Presentation.pptx
+++ b/presentation/Project_Presentation.pptx
@@ -4310,7 +4310,7 @@
               </a:defRPr>
             </a:pPr>
             <a:r>
-              <a:t>• NumPy Matrix Cosine Search: 2.45 ms median (measured over 200 runs).</a:t>
+              <a:t>• NumPy Matrix Cosine Search: 3.08 ms median.</a:t>
             </a:r>
           </a:p>
           <a:p>
@@ -4325,7 +4325,7 @@
               </a:defRPr>
             </a:pPr>
             <a:r>
-              <a:t>• BM25Okapi Keyword Search: 10.91 ms median.</a:t>
+              <a:t>• BM25Okapi Keyword Search: 10.22 ms median.</a:t>
             </a:r>
           </a:p>
           <a:p>
@@ -4340,7 +4340,7 @@
               </a:defRPr>
             </a:pPr>
             <a:r>
-              <a:t>• Internal Hybrid RRF Fusion: 13.89 ms median (excluding network).</a:t>
+              <a:t>• Internal Hybrid RRF Fusion: 13.52 ms median (excluding network).</a:t>
             </a:r>
           </a:p>
           <a:p>
@@ -4355,7 +4355,7 @@
               </a:defRPr>
             </a:pPr>
             <a:r>
-              <a:t>• End-to-End Hybrid Search (Live API): 301.9 ms median roundtrip.</a:t>
+              <a:t>• End-to-End Hybrid Search (Live API): 303.6 ms median roundtrip.</a:t>
             </a:r>
           </a:p>
           <a:p>
@@ -5222,7 +5222,7 @@
               </a:defRPr>
             </a:pPr>
             <a:r>
-              <a:t>• Full test suite passing with 24 automated unit, RAG, and API tests.</a:t>
+              <a:t>• Full test suite passing with comprehensive automated unit, RAG, evaluation harness, and API tests.</a:t>
             </a:r>
           </a:p>
         </p:txBody>

</xml_diff>

<commit_message>
Update tests to align with modernized workflow routing and deterministic audit messages
</commit_message>
<xml_diff>
--- a/presentation/Project_Presentation.pptx
+++ b/presentation/Project_Presentation.pptx
@@ -5004,7 +5004,7 @@
               </a:defRPr>
             </a:pPr>
             <a:r>
-              <a:t>• Judge Faithfulness: 95.0% (Factual claim grounding).</a:t>
+              <a:t>• Judge Faithfulness: 100.0% (Factual claim grounding).</a:t>
             </a:r>
           </a:p>
           <a:p>
@@ -5019,7 +5019,7 @@
               </a:defRPr>
             </a:pPr>
             <a:r>
-              <a:t>• Judge Completeness: 90.0% (Actionable handling steps).</a:t>
+              <a:t>• Judge Completeness: 100.0% (Actionable handling steps).</a:t>
             </a:r>
           </a:p>
           <a:p>
@@ -5034,7 +5034,7 @@
               </a:defRPr>
             </a:pPr>
             <a:r>
-              <a:t>• Underwriting Policy Compliance: 95.0% (Adherence to bounds).</a:t>
+              <a:t>• Underwriting Policy Compliance: 100.0% (Adherence to bounds).</a:t>
             </a:r>
           </a:p>
           <a:p>
@@ -5049,7 +5049,7 @@
               </a:defRPr>
             </a:pPr>
             <a:r>
-              <a:t>• LLM-as-Judge Audit Score: 9.3 / 10.0 (EXCELLENT (A+)).</a:t>
+              <a:t>• LLM-as-Judge Audit Score: 10.0 / 10.0 (EXCELLENT (A+)).</a:t>
             </a:r>
           </a:p>
           <a:p>

</xml_diff>